<commit_message>
Add Lecture 14 and update Week 6 notes
This commit adds the Friday Oct 2 lecture deck and supporting figures for statistical significance and introductory probability, and updates the Week 6 schedule and lecture index to reflect the carry-over from Lecture 13. It also refreshes the rendered HTML/PDF outputs and adds the new lecture assets used in the slides.
</commit_message>
<xml_diff>
--- a/docs/lecture_slides/Week 6/Week6_Lecture13_Slides_9_30_2026.pptx
+++ b/docs/lecture_slides/Week 6/Week6_Lecture13_Slides_9_30_2026.pptx
@@ -26,13 +26,6 @@
     <p:sldId id="352" r:id="rId20"/>
     <p:sldId id="353" r:id="rId21"/>
     <p:sldId id="354" r:id="rId22"/>
-    <p:sldId id="355" r:id="rId23"/>
-    <p:sldId id="345" r:id="rId24"/>
-    <p:sldId id="364" r:id="rId25"/>
-    <p:sldId id="365" r:id="rId26"/>
-    <p:sldId id="366" r:id="rId27"/>
-    <p:sldId id="367" r:id="rId28"/>
-    <p:sldId id="368" r:id="rId29"/>
   </p:sldIdLst>
   <p:sldSz cx="12192000" cy="6858000"/>
   <p:notesSz cx="6858000" cy="9144000"/>
@@ -10511,4124 +10504,6 @@
     <p:extLst>
       <p:ext uri="{BB962C8B-B14F-4D97-AF65-F5344CB8AC3E}">
         <p14:creationId xmlns:p14="http://schemas.microsoft.com/office/powerpoint/2010/main" val="582668286"/>
-      </p:ext>
-    </p:extLst>
-  </p:cSld>
-  <p:clrMapOvr>
-    <a:masterClrMapping/>
-  </p:clrMapOvr>
-  <p:timing>
-    <p:tnLst>
-      <p:par>
-        <p:cTn id="1" dur="indefinite" restart="never" nodeType="tmRoot">
-          <p:childTnLst>
-            <p:seq concurrent="1" nextAc="seek">
-              <p:cTn id="2" dur="indefinite" nodeType="mainSeq">
-                <p:childTnLst>
-                  <p:par>
-                    <p:cTn id="3" fill="hold">
-                      <p:stCondLst>
-                        <p:cond delay="indefinite"/>
-                      </p:stCondLst>
-                      <p:childTnLst>
-                        <p:par>
-                          <p:cTn id="4" fill="hold">
-                            <p:stCondLst>
-                              <p:cond delay="0"/>
-                            </p:stCondLst>
-                            <p:childTnLst>
-                              <p:par>
-                                <p:cTn id="5" presetID="1" presetClass="entr" presetSubtype="0" fill="hold" grpId="0" nodeType="clickEffect">
-                                  <p:stCondLst>
-                                    <p:cond delay="0"/>
-                                  </p:stCondLst>
-                                  <p:childTnLst>
-                                    <p:set>
-                                      <p:cBhvr>
-                                        <p:cTn id="6" dur="1" fill="hold">
-                                          <p:stCondLst>
-                                            <p:cond delay="0"/>
-                                          </p:stCondLst>
-                                        </p:cTn>
-                                        <p:tgtEl>
-                                          <p:spTgt spid="11"/>
-                                        </p:tgtEl>
-                                        <p:attrNameLst>
-                                          <p:attrName>style.visibility</p:attrName>
-                                        </p:attrNameLst>
-                                      </p:cBhvr>
-                                      <p:to>
-                                        <p:strVal val="visible"/>
-                                      </p:to>
-                                    </p:set>
-                                  </p:childTnLst>
-                                </p:cTn>
-                              </p:par>
-                            </p:childTnLst>
-                          </p:cTn>
-                        </p:par>
-                      </p:childTnLst>
-                    </p:cTn>
-                  </p:par>
-                </p:childTnLst>
-              </p:cTn>
-              <p:prevCondLst>
-                <p:cond evt="onPrev" delay="0">
-                  <p:tgtEl>
-                    <p:sldTgt/>
-                  </p:tgtEl>
-                </p:cond>
-              </p:prevCondLst>
-              <p:nextCondLst>
-                <p:cond evt="onNext" delay="0">
-                  <p:tgtEl>
-                    <p:sldTgt/>
-                  </p:tgtEl>
-                </p:cond>
-              </p:nextCondLst>
-            </p:seq>
-          </p:childTnLst>
-        </p:cTn>
-      </p:par>
-    </p:tnLst>
-    <p:bldLst>
-      <p:bldP spid="11" grpId="0" animBg="1"/>
-    </p:bldLst>
-  </p:timing>
-</p:sld>
-</file>
-
-<file path=ppt/slides/slide22.xml><?xml version="1.0" encoding="utf-8"?>
-<p:sld xmlns:a="http://schemas.openxmlformats.org/drawingml/2006/main" xmlns:r="http://schemas.openxmlformats.org/officeDocument/2006/relationships" xmlns:p="http://schemas.openxmlformats.org/presentationml/2006/main">
-  <p:cSld>
-    <p:spTree>
-      <p:nvGrpSpPr>
-        <p:cNvPr id="1" name=""/>
-        <p:cNvGrpSpPr/>
-        <p:nvPr/>
-      </p:nvGrpSpPr>
-      <p:grpSpPr>
-        <a:xfrm>
-          <a:off x="0" y="0"/>
-          <a:ext cx="0" cy="0"/>
-          <a:chOff x="0" y="0"/>
-          <a:chExt cx="0" cy="0"/>
-        </a:xfrm>
-      </p:grpSpPr>
-      <p:sp>
-        <p:nvSpPr>
-          <p:cNvPr id="2" name="Title 1">
-            <a:extLst>
-              <a:ext uri="{FF2B5EF4-FFF2-40B4-BE49-F238E27FC236}">
-                <a16:creationId xmlns:a16="http://schemas.microsoft.com/office/drawing/2014/main" id="{C08D30B1-1864-30EF-7EAB-9BEE656C0012}"/>
-              </a:ext>
-            </a:extLst>
-          </p:cNvPr>
-          <p:cNvSpPr>
-            <a:spLocks noGrp="1"/>
-          </p:cNvSpPr>
-          <p:nvPr>
-            <p:ph type="title"/>
-          </p:nvPr>
-        </p:nvSpPr>
-        <p:spPr/>
-        <p:txBody>
-          <a:bodyPr>
-            <a:noAutofit/>
-          </a:bodyPr>
-          <a:lstStyle/>
-          <a:p>
-            <a:r>
-              <a:rPr lang="en-US">
-                <a:solidFill>
-                  <a:srgbClr val="1F3864"/>
-                </a:solidFill>
-              </a:rPr>
-              <a:t>Statistical significance</a:t>
-            </a:r>
-          </a:p>
-        </p:txBody>
-      </p:sp>
-      <p:sp>
-        <p:nvSpPr>
-          <p:cNvPr id="4" name="Slide Number Placeholder 3">
-            <a:extLst>
-              <a:ext uri="{FF2B5EF4-FFF2-40B4-BE49-F238E27FC236}">
-                <a16:creationId xmlns:a16="http://schemas.microsoft.com/office/drawing/2014/main" id="{3F875068-D051-44AE-498E-1BEBEDE3A7C8}"/>
-              </a:ext>
-            </a:extLst>
-          </p:cNvPr>
-          <p:cNvSpPr>
-            <a:spLocks noGrp="1"/>
-          </p:cNvSpPr>
-          <p:nvPr>
-            <p:ph type="sldNum" sz="quarter" idx="12"/>
-          </p:nvPr>
-        </p:nvSpPr>
-        <p:spPr/>
-        <p:txBody>
-          <a:bodyPr/>
-          <a:lstStyle/>
-          <a:p>
-            <a:fld id="{A80A81DD-F10A-4B1C-963A-0ABBB4865886}" type="slidenum">
-              <a:rPr lang="en-US" sz="1600" smtClean="0"/>
-              <a:t>22</a:t>
-            </a:fld>
-            <a:endParaRPr lang="en-US" sz="1600"/>
-          </a:p>
-        </p:txBody>
-      </p:sp>
-      <p:sp>
-        <p:nvSpPr>
-          <p:cNvPr id="3" name="Title rule">
-            <a:extLst>
-              <a:ext uri="{FF2B5EF4-FFF2-40B4-BE49-F238E27FC236}">
-                <a16:creationId xmlns:a16="http://schemas.microsoft.com/office/drawing/2014/main" id="{30656AA8-9645-F028-C769-A313710853CC}"/>
-              </a:ext>
-            </a:extLst>
-          </p:cNvPr>
-          <p:cNvSpPr/>
-          <p:nvPr/>
-        </p:nvSpPr>
-        <p:spPr>
-          <a:xfrm>
-            <a:off x="838200" y="1600200"/>
-            <a:ext cx="10515600" cy="38100"/>
-          </a:xfrm>
-          <a:prstGeom prst="rect">
-            <a:avLst/>
-          </a:prstGeom>
-          <a:solidFill>
-            <a:srgbClr val="4472C4"/>
-          </a:solidFill>
-          <a:ln w="12700" cap="flat" cmpd="sng" algn="ctr">
-            <a:noFill/>
-            <a:prstDash val="solid"/>
-            <a:miter lim="800000"/>
-          </a:ln>
-          <a:effectLst/>
-          <a:extLst>
-            <a:ext uri="{91240B29-F687-4F45-9708-019B960494DF}">
-              <a14:hiddenLine xmlns:a14="http://schemas.microsoft.com/office/drawing/2010/main" w="12700" cap="flat" cmpd="sng" algn="ctr">
-                <a:solidFill>
-                  <a:schemeClr val="accent1">
-                    <a:shade val="15000"/>
-                  </a:schemeClr>
-                </a:solidFill>
-                <a:prstDash val="solid"/>
-                <a:miter lim="800000"/>
-              </a14:hiddenLine>
-            </a:ext>
-          </a:extLst>
-        </p:spPr>
-        <p:style>
-          <a:lnRef idx="2">
-            <a:schemeClr val="accent1">
-              <a:shade val="15000"/>
-            </a:schemeClr>
-          </a:lnRef>
-          <a:fillRef idx="1">
-            <a:schemeClr val="accent1"/>
-          </a:fillRef>
-          <a:effectRef idx="0">
-            <a:schemeClr val="accent1"/>
-          </a:effectRef>
-          <a:fontRef idx="minor">
-            <a:schemeClr val="lt1"/>
-          </a:fontRef>
-        </p:style>
-        <p:txBody>
-          <a:bodyPr rtlCol="0" anchor="ctr"/>
-          <a:lstStyle/>
-          <a:p>
-            <a:pPr algn="ctr"/>
-            <a:endParaRPr lang="en-US"/>
-          </a:p>
-        </p:txBody>
-      </p:sp>
-      <p:sp>
-        <p:nvSpPr>
-          <p:cNvPr id="8" name="Context">
-            <a:extLst>
-              <a:ext uri="{FF2B5EF4-FFF2-40B4-BE49-F238E27FC236}">
-                <a16:creationId xmlns:a16="http://schemas.microsoft.com/office/drawing/2014/main" id="{71E3EA8C-31B4-DAD4-BC4A-65D72E59AD46}"/>
-              </a:ext>
-            </a:extLst>
-          </p:cNvPr>
-          <p:cNvSpPr txBox="1"/>
-          <p:nvPr/>
-        </p:nvSpPr>
-        <p:spPr>
-          <a:xfrm>
-            <a:off x="762000" y="1879600"/>
-            <a:ext cx="10668000" cy="381000"/>
-          </a:xfrm>
-          <a:prstGeom prst="rect">
-            <a:avLst/>
-          </a:prstGeom>
-          <a:noFill/>
-        </p:spPr>
-        <p:txBody>
-          <a:bodyPr vert="horz" wrap="square" rtlCol="0">
-            <a:spAutoFit/>
-          </a:bodyPr>
-          <a:lstStyle/>
-          <a:p>
-            <a:pPr>
-              <a:spcAft>
-                <a:spcPts val="200"/>
-              </a:spcAft>
-            </a:pPr>
-            <a:r>
-              <a:rPr lang="en-US">
-                <a:solidFill>
-                  <a:srgbClr val="000000"/>
-                </a:solidFill>
-                <a:latin typeface="Calibri" panose="020F0502020204030204" pitchFamily="34" charset="0"/>
-              </a:rPr>
-              <a:t>Someone hands you 20 students and says they are a random sample of all 379.</a:t>
-            </a:r>
-          </a:p>
-        </p:txBody>
-      </p:sp>
-      <p:sp>
-        <p:nvSpPr>
-          <p:cNvPr id="9" name="Numbers">
-            <a:extLst>
-              <a:ext uri="{FF2B5EF4-FFF2-40B4-BE49-F238E27FC236}">
-                <a16:creationId xmlns:a16="http://schemas.microsoft.com/office/drawing/2014/main" id="{C419F151-05B2-3E4B-BAE8-BB1F06D9D1FD}"/>
-              </a:ext>
-            </a:extLst>
-          </p:cNvPr>
-          <p:cNvSpPr txBox="1"/>
-          <p:nvPr/>
-        </p:nvSpPr>
-        <p:spPr>
-          <a:xfrm>
-            <a:off x="762000" y="2286000"/>
-            <a:ext cx="10668000" cy="400110"/>
-          </a:xfrm>
-          <a:prstGeom prst="rect">
-            <a:avLst/>
-          </a:prstGeom>
-          <a:noFill/>
-        </p:spPr>
-        <p:txBody>
-          <a:bodyPr vert="horz" wrap="square" rtlCol="0">
-            <a:spAutoFit/>
-          </a:bodyPr>
-          <a:lstStyle/>
-          <a:p>
-            <a:pPr>
-              <a:spcAft>
-                <a:spcPts val="200"/>
-              </a:spcAft>
-            </a:pPr>
-            <a:r>
-              <a:rPr lang="it-IT" sz="2000" b="1">
-                <a:solidFill>
-                  <a:srgbClr val="000000"/>
-                </a:solidFill>
-                <a:latin typeface="Calibri" panose="020F0502020204030204" pitchFamily="34" charset="0"/>
-              </a:rPr>
-              <a:t>x̄ = 70.33 in        μ = 67.1 in        SE = 0.92 in</a:t>
-            </a:r>
-            <a:endParaRPr lang="en-US" sz="2000" b="1">
-              <a:solidFill>
-                <a:srgbClr val="000000"/>
-              </a:solidFill>
-              <a:latin typeface="Calibri" panose="020F0502020204030204" pitchFamily="34" charset="0"/>
-            </a:endParaRPr>
-          </a:p>
-        </p:txBody>
-      </p:sp>
-      <p:sp>
-        <p:nvSpPr>
-          <p:cNvPr id="10" name="Question">
-            <a:extLst>
-              <a:ext uri="{FF2B5EF4-FFF2-40B4-BE49-F238E27FC236}">
-                <a16:creationId xmlns:a16="http://schemas.microsoft.com/office/drawing/2014/main" id="{B31E395F-B84E-D1E9-D22A-222467FC4105}"/>
-              </a:ext>
-            </a:extLst>
-          </p:cNvPr>
-          <p:cNvSpPr txBox="1"/>
-          <p:nvPr/>
-        </p:nvSpPr>
-        <p:spPr>
-          <a:xfrm>
-            <a:off x="762000" y="2711510"/>
-            <a:ext cx="10668000" cy="369332"/>
-          </a:xfrm>
-          <a:prstGeom prst="rect">
-            <a:avLst/>
-          </a:prstGeom>
-          <a:noFill/>
-        </p:spPr>
-        <p:txBody>
-          <a:bodyPr vert="horz" wrap="square" rtlCol="0">
-            <a:spAutoFit/>
-          </a:bodyPr>
-          <a:lstStyle/>
-          <a:p>
-            <a:pPr>
-              <a:spcAft>
-                <a:spcPts val="200"/>
-              </a:spcAft>
-            </a:pPr>
-            <a:r>
-              <a:rPr lang="en-US" b="1">
-                <a:solidFill>
-                  <a:srgbClr val="C00000"/>
-                </a:solidFill>
-                <a:latin typeface="Calibri" panose="020F0502020204030204" pitchFamily="34" charset="0"/>
-              </a:rPr>
-              <a:t>Is this result statistically significant?</a:t>
-            </a:r>
-          </a:p>
-        </p:txBody>
-      </p:sp>
-      <p:sp>
-        <p:nvSpPr>
-          <p:cNvPr id="11" name="Result">
-            <a:extLst>
-              <a:ext uri="{FF2B5EF4-FFF2-40B4-BE49-F238E27FC236}">
-                <a16:creationId xmlns:a16="http://schemas.microsoft.com/office/drawing/2014/main" id="{5A70F68E-0D93-07B8-82B2-4D8F2F681D0D}"/>
-              </a:ext>
-            </a:extLst>
-          </p:cNvPr>
-          <p:cNvSpPr/>
-          <p:nvPr/>
-        </p:nvSpPr>
-        <p:spPr>
-          <a:xfrm>
-            <a:off x="762000" y="3233242"/>
-            <a:ext cx="10668000" cy="784324"/>
-          </a:xfrm>
-          <a:prstGeom prst="roundRect">
-            <a:avLst>
-              <a:gd name="adj" fmla="val 4000"/>
-            </a:avLst>
-          </a:prstGeom>
-          <a:solidFill>
-            <a:srgbClr val="F2F6FC"/>
-          </a:solidFill>
-          <a:ln w="15875">
-            <a:solidFill>
-              <a:srgbClr val="4472C4"/>
-            </a:solidFill>
-          </a:ln>
-        </p:spPr>
-        <p:style>
-          <a:lnRef idx="2">
-            <a:schemeClr val="accent1">
-              <a:shade val="15000"/>
-            </a:schemeClr>
-          </a:lnRef>
-          <a:fillRef idx="1">
-            <a:schemeClr val="accent1"/>
-          </a:fillRef>
-          <a:effectRef idx="0">
-            <a:schemeClr val="accent1"/>
-          </a:effectRef>
-          <a:fontRef idx="minor">
-            <a:schemeClr val="lt1"/>
-          </a:fontRef>
-        </p:style>
-        <p:txBody>
-          <a:bodyPr wrap="square" lIns="152400" tIns="76200" rIns="152400" bIns="76200" rtlCol="0" anchor="ctr">
-            <a:spAutoFit/>
-          </a:bodyPr>
-          <a:lstStyle/>
-          <a:p>
-            <a:r>
-              <a:rPr lang="en-US" sz="2000" b="1">
-                <a:solidFill>
-                  <a:srgbClr val="C00000"/>
-                </a:solidFill>
-                <a:latin typeface="Calibri" panose="020F0502020204030204" pitchFamily="34" charset="0"/>
-              </a:rPr>
-              <a:t>z = (70.33 − 67.1) / 0.92 ≈ 3.5:  far outside the margin of error, so yes</a:t>
-            </a:r>
-          </a:p>
-          <a:p>
-            <a:r>
-              <a:rPr lang="en-US" b="1">
-                <a:solidFill>
-                  <a:srgbClr val="C00000"/>
-                </a:solidFill>
-                <a:latin typeface="Calibri" panose="020F0502020204030204" pitchFamily="34" charset="0"/>
-              </a:rPr>
-              <a:t>Statistically significant: this was not a random sample of all students (they were all men)</a:t>
-            </a:r>
-          </a:p>
-        </p:txBody>
-      </p:sp>
-    </p:spTree>
-    <p:extLst>
-      <p:ext uri="{BB962C8B-B14F-4D97-AF65-F5344CB8AC3E}">
-        <p14:creationId xmlns:p14="http://schemas.microsoft.com/office/powerpoint/2010/main" val="901969607"/>
-      </p:ext>
-    </p:extLst>
-  </p:cSld>
-  <p:clrMapOvr>
-    <a:masterClrMapping/>
-  </p:clrMapOvr>
-  <p:timing>
-    <p:tnLst>
-      <p:par>
-        <p:cTn id="1" dur="indefinite" restart="never" nodeType="tmRoot">
-          <p:childTnLst>
-            <p:seq concurrent="1" nextAc="seek">
-              <p:cTn id="2" dur="indefinite" nodeType="mainSeq">
-                <p:childTnLst>
-                  <p:par>
-                    <p:cTn id="3" fill="hold">
-                      <p:stCondLst>
-                        <p:cond delay="indefinite"/>
-                      </p:stCondLst>
-                      <p:childTnLst>
-                        <p:par>
-                          <p:cTn id="4" fill="hold">
-                            <p:stCondLst>
-                              <p:cond delay="0"/>
-                            </p:stCondLst>
-                            <p:childTnLst>
-                              <p:par>
-                                <p:cTn id="5" presetID="1" presetClass="entr" presetSubtype="0" fill="hold" grpId="0" nodeType="clickEffect">
-                                  <p:stCondLst>
-                                    <p:cond delay="0"/>
-                                  </p:stCondLst>
-                                  <p:childTnLst>
-                                    <p:set>
-                                      <p:cBhvr>
-                                        <p:cTn id="6" dur="1" fill="hold">
-                                          <p:stCondLst>
-                                            <p:cond delay="0"/>
-                                          </p:stCondLst>
-                                        </p:cTn>
-                                        <p:tgtEl>
-                                          <p:spTgt spid="11"/>
-                                        </p:tgtEl>
-                                        <p:attrNameLst>
-                                          <p:attrName>style.visibility</p:attrName>
-                                        </p:attrNameLst>
-                                      </p:cBhvr>
-                                      <p:to>
-                                        <p:strVal val="visible"/>
-                                      </p:to>
-                                    </p:set>
-                                  </p:childTnLst>
-                                </p:cTn>
-                              </p:par>
-                            </p:childTnLst>
-                          </p:cTn>
-                        </p:par>
-                      </p:childTnLst>
-                    </p:cTn>
-                  </p:par>
-                </p:childTnLst>
-              </p:cTn>
-              <p:prevCondLst>
-                <p:cond evt="onPrev" delay="0">
-                  <p:tgtEl>
-                    <p:sldTgt/>
-                  </p:tgtEl>
-                </p:cond>
-              </p:prevCondLst>
-              <p:nextCondLst>
-                <p:cond evt="onNext" delay="0">
-                  <p:tgtEl>
-                    <p:sldTgt/>
-                  </p:tgtEl>
-                </p:cond>
-              </p:nextCondLst>
-            </p:seq>
-          </p:childTnLst>
-        </p:cTn>
-      </p:par>
-    </p:tnLst>
-    <p:bldLst>
-      <p:bldP spid="11" grpId="0" animBg="1"/>
-    </p:bldLst>
-  </p:timing>
-</p:sld>
-</file>
-
-<file path=ppt/slides/slide23.xml><?xml version="1.0" encoding="utf-8"?>
-<p:sld xmlns:a="http://schemas.openxmlformats.org/drawingml/2006/main" xmlns:r="http://schemas.openxmlformats.org/officeDocument/2006/relationships" xmlns:p="http://schemas.openxmlformats.org/presentationml/2006/main">
-  <p:cSld>
-    <p:spTree>
-      <p:nvGrpSpPr>
-        <p:cNvPr id="1" name=""/>
-        <p:cNvGrpSpPr/>
-        <p:nvPr/>
-      </p:nvGrpSpPr>
-      <p:grpSpPr>
-        <a:xfrm>
-          <a:off x="0" y="0"/>
-          <a:ext cx="0" cy="0"/>
-          <a:chOff x="0" y="0"/>
-          <a:chExt cx="0" cy="0"/>
-        </a:xfrm>
-      </p:grpSpPr>
-      <p:sp>
-        <p:nvSpPr>
-          <p:cNvPr id="2" name="Title 1">
-            <a:extLst>
-              <a:ext uri="{FF2B5EF4-FFF2-40B4-BE49-F238E27FC236}">
-                <a16:creationId xmlns:a16="http://schemas.microsoft.com/office/drawing/2014/main" id="{D617AB41-6AD1-9EF2-7F95-46A904399681}"/>
-              </a:ext>
-            </a:extLst>
-          </p:cNvPr>
-          <p:cNvSpPr>
-            <a:spLocks noGrp="1"/>
-          </p:cNvSpPr>
-          <p:nvPr>
-            <p:ph type="title"/>
-          </p:nvPr>
-        </p:nvSpPr>
-        <p:spPr/>
-        <p:txBody>
-          <a:bodyPr>
-            <a:noAutofit/>
-          </a:bodyPr>
-          <a:lstStyle/>
-          <a:p>
-            <a:r>
-              <a:rPr lang="en-US">
-                <a:solidFill>
-                  <a:srgbClr val="1F3864"/>
-                </a:solidFill>
-              </a:rPr>
-              <a:t>What you should know: the normal distribution</a:t>
-            </a:r>
-          </a:p>
-        </p:txBody>
-      </p:sp>
-      <p:sp>
-        <p:nvSpPr>
-          <p:cNvPr id="4" name="Slide Number Placeholder 3">
-            <a:extLst>
-              <a:ext uri="{FF2B5EF4-FFF2-40B4-BE49-F238E27FC236}">
-                <a16:creationId xmlns:a16="http://schemas.microsoft.com/office/drawing/2014/main" id="{97D44AE5-98B5-B840-6B8A-D345C7C2E2F0}"/>
-              </a:ext>
-            </a:extLst>
-          </p:cNvPr>
-          <p:cNvSpPr>
-            <a:spLocks noGrp="1"/>
-          </p:cNvSpPr>
-          <p:nvPr>
-            <p:ph type="sldNum" sz="quarter" idx="12"/>
-          </p:nvPr>
-        </p:nvSpPr>
-        <p:spPr/>
-        <p:txBody>
-          <a:bodyPr/>
-          <a:lstStyle/>
-          <a:p>
-            <a:fld id="{A80A81DD-F10A-4B1C-963A-0ABBB4865886}" type="slidenum">
-              <a:rPr lang="en-US" sz="1600" smtClean="0"/>
-              <a:t>23</a:t>
-            </a:fld>
-            <a:endParaRPr lang="en-US" sz="1600"/>
-          </a:p>
-        </p:txBody>
-      </p:sp>
-      <p:sp>
-        <p:nvSpPr>
-          <p:cNvPr id="5" name="TextBox 4">
-            <a:extLst>
-              <a:ext uri="{FF2B5EF4-FFF2-40B4-BE49-F238E27FC236}">
-                <a16:creationId xmlns:a16="http://schemas.microsoft.com/office/drawing/2014/main" id="{A34AAE17-27CE-D7A3-C663-11BB48ACBF5B}"/>
-              </a:ext>
-            </a:extLst>
-          </p:cNvPr>
-          <p:cNvSpPr txBox="1"/>
-          <p:nvPr/>
-        </p:nvSpPr>
-        <p:spPr>
-          <a:xfrm>
-            <a:off x="762000" y="1879600"/>
-            <a:ext cx="10668000" cy="345440"/>
-          </a:xfrm>
-          <a:prstGeom prst="rect">
-            <a:avLst/>
-          </a:prstGeom>
-          <a:noFill/>
-        </p:spPr>
-        <p:txBody>
-          <a:bodyPr vert="horz" wrap="square" rtlCol="0">
-            <a:spAutoFit/>
-          </a:bodyPr>
-          <a:lstStyle/>
-          <a:p>
-            <a:pPr marL="304800" indent="-304800"/>
-            <a:r>
-              <a:rPr lang="en-US" sz="1600">
-                <a:solidFill>
-                  <a:srgbClr val="000000"/>
-                </a:solidFill>
-              </a:rPr>
-              <a:t>The two parameters</a:t>
-            </a:r>
-          </a:p>
-        </p:txBody>
-      </p:sp>
-      <p:sp>
-        <p:nvSpPr>
-          <p:cNvPr id="6" name="TextBox 5">
-            <a:extLst>
-              <a:ext uri="{FF2B5EF4-FFF2-40B4-BE49-F238E27FC236}">
-                <a16:creationId xmlns:a16="http://schemas.microsoft.com/office/drawing/2014/main" id="{E410A0F8-5E1E-9A1D-B64C-50827EE6C9B2}"/>
-              </a:ext>
-            </a:extLst>
-          </p:cNvPr>
-          <p:cNvSpPr txBox="1"/>
-          <p:nvPr/>
-        </p:nvSpPr>
-        <p:spPr>
-          <a:xfrm>
-            <a:off x="1117600" y="2225040"/>
-            <a:ext cx="10312400" cy="338554"/>
-          </a:xfrm>
-          <a:prstGeom prst="rect">
-            <a:avLst/>
-          </a:prstGeom>
-          <a:noFill/>
-        </p:spPr>
-        <p:txBody>
-          <a:bodyPr vert="horz" wrap="square" rtlCol="0">
-            <a:spAutoFit/>
-          </a:bodyPr>
-          <a:lstStyle/>
-          <a:p>
-            <a:r>
-              <a:rPr lang="en-US" sz="1600" b="1">
-                <a:solidFill>
-                  <a:srgbClr val="C00000"/>
-                </a:solidFill>
-              </a:rPr>
-              <a:t>x ~ N(μ, σ):  μ locates the center, σ sets the spread.</a:t>
-            </a:r>
-          </a:p>
-        </p:txBody>
-      </p:sp>
-      <p:sp>
-        <p:nvSpPr>
-          <p:cNvPr id="7" name="TextBox 6">
-            <a:extLst>
-              <a:ext uri="{FF2B5EF4-FFF2-40B4-BE49-F238E27FC236}">
-                <a16:creationId xmlns:a16="http://schemas.microsoft.com/office/drawing/2014/main" id="{47D3CD95-D52E-5227-B663-7C0A72677B6E}"/>
-              </a:ext>
-            </a:extLst>
-          </p:cNvPr>
-          <p:cNvSpPr txBox="1"/>
-          <p:nvPr/>
-        </p:nvSpPr>
-        <p:spPr>
-          <a:xfrm>
-            <a:off x="762000" y="2766794"/>
-            <a:ext cx="10668000" cy="345440"/>
-          </a:xfrm>
-          <a:prstGeom prst="rect">
-            <a:avLst/>
-          </a:prstGeom>
-          <a:noFill/>
-        </p:spPr>
-        <p:txBody>
-          <a:bodyPr vert="horz" wrap="square" rtlCol="0">
-            <a:spAutoFit/>
-          </a:bodyPr>
-          <a:lstStyle/>
-          <a:p>
-            <a:pPr marL="304800" indent="-304800"/>
-            <a:r>
-              <a:rPr lang="en-US" sz="1600">
-                <a:solidFill>
-                  <a:srgbClr val="000000"/>
-                </a:solidFill>
-              </a:rPr>
-              <a:t>The empirical rule</a:t>
-            </a:r>
-          </a:p>
-        </p:txBody>
-      </p:sp>
-      <p:sp>
-        <p:nvSpPr>
-          <p:cNvPr id="8" name="TextBox 7">
-            <a:extLst>
-              <a:ext uri="{FF2B5EF4-FFF2-40B4-BE49-F238E27FC236}">
-                <a16:creationId xmlns:a16="http://schemas.microsoft.com/office/drawing/2014/main" id="{1CE3E601-601D-C6B1-8265-C079CB8C9269}"/>
-              </a:ext>
-            </a:extLst>
-          </p:cNvPr>
-          <p:cNvSpPr txBox="1"/>
-          <p:nvPr/>
-        </p:nvSpPr>
-        <p:spPr>
-          <a:xfrm>
-            <a:off x="1117600" y="3112234"/>
-            <a:ext cx="10312400" cy="338554"/>
-          </a:xfrm>
-          <a:prstGeom prst="rect">
-            <a:avLst/>
-          </a:prstGeom>
-          <a:noFill/>
-        </p:spPr>
-        <p:txBody>
-          <a:bodyPr vert="horz" wrap="square" rtlCol="0">
-            <a:spAutoFit/>
-          </a:bodyPr>
-          <a:lstStyle/>
-          <a:p>
-            <a:r>
-              <a:rPr lang="en-US" sz="1600" b="1">
-                <a:solidFill>
-                  <a:srgbClr val="C00000"/>
-                </a:solidFill>
-              </a:rPr>
-              <a:t>68%, 95% and 99.7% within 1, 2 and 3 standard deviations (bell-shaped only).</a:t>
-            </a:r>
-          </a:p>
-        </p:txBody>
-      </p:sp>
-      <p:sp>
-        <p:nvSpPr>
-          <p:cNvPr id="9" name="TextBox 8">
-            <a:extLst>
-              <a:ext uri="{FF2B5EF4-FFF2-40B4-BE49-F238E27FC236}">
-                <a16:creationId xmlns:a16="http://schemas.microsoft.com/office/drawing/2014/main" id="{FB002BF4-8037-2F73-E27A-7A453477E389}"/>
-              </a:ext>
-            </a:extLst>
-          </p:cNvPr>
-          <p:cNvSpPr txBox="1"/>
-          <p:nvPr/>
-        </p:nvSpPr>
-        <p:spPr>
-          <a:xfrm>
-            <a:off x="762000" y="3653988"/>
-            <a:ext cx="10668000" cy="345440"/>
-          </a:xfrm>
-          <a:prstGeom prst="rect">
-            <a:avLst/>
-          </a:prstGeom>
-          <a:noFill/>
-        </p:spPr>
-        <p:txBody>
-          <a:bodyPr vert="horz" wrap="square" rtlCol="0">
-            <a:spAutoFit/>
-          </a:bodyPr>
-          <a:lstStyle/>
-          <a:p>
-            <a:pPr marL="304800" indent="-304800"/>
-            <a:r>
-              <a:rPr lang="en-US" sz="1600">
-                <a:solidFill>
-                  <a:srgbClr val="000000"/>
-                </a:solidFill>
-              </a:rPr>
-              <a:t>The z-score</a:t>
-            </a:r>
-          </a:p>
-        </p:txBody>
-      </p:sp>
-      <p:sp>
-        <p:nvSpPr>
-          <p:cNvPr id="10" name="TextBox 9">
-            <a:extLst>
-              <a:ext uri="{FF2B5EF4-FFF2-40B4-BE49-F238E27FC236}">
-                <a16:creationId xmlns:a16="http://schemas.microsoft.com/office/drawing/2014/main" id="{10F3B3E3-D27C-E008-C93E-ED70BD2A4754}"/>
-              </a:ext>
-            </a:extLst>
-          </p:cNvPr>
-          <p:cNvSpPr txBox="1"/>
-          <p:nvPr/>
-        </p:nvSpPr>
-        <p:spPr>
-          <a:xfrm>
-            <a:off x="1117600" y="3999428"/>
-            <a:ext cx="10312400" cy="338554"/>
-          </a:xfrm>
-          <a:prstGeom prst="rect">
-            <a:avLst/>
-          </a:prstGeom>
-          <a:noFill/>
-        </p:spPr>
-        <p:txBody>
-          <a:bodyPr vert="horz" wrap="square" rtlCol="0">
-            <a:spAutoFit/>
-          </a:bodyPr>
-          <a:lstStyle/>
-          <a:p>
-            <a:r>
-              <a:rPr lang="en-US" sz="1600" b="1">
-                <a:solidFill>
-                  <a:srgbClr val="C00000"/>
-                </a:solidFill>
-              </a:rPr>
-              <a:t>z = (x − x̄) / s counts standard deviations from the mean;  |z| ≥ 2 flags an outlier.</a:t>
-            </a:r>
-          </a:p>
-        </p:txBody>
-      </p:sp>
-      <p:sp>
-        <p:nvSpPr>
-          <p:cNvPr id="3" name="Title rule">
-            <a:extLst>
-              <a:ext uri="{FF2B5EF4-FFF2-40B4-BE49-F238E27FC236}">
-                <a16:creationId xmlns:a16="http://schemas.microsoft.com/office/drawing/2014/main" id="{B469CAAB-2B69-6863-7C28-0C5959E5734B}"/>
-              </a:ext>
-            </a:extLst>
-          </p:cNvPr>
-          <p:cNvSpPr/>
-          <p:nvPr/>
-        </p:nvSpPr>
-        <p:spPr>
-          <a:xfrm>
-            <a:off x="838200" y="1600200"/>
-            <a:ext cx="10515600" cy="38100"/>
-          </a:xfrm>
-          <a:prstGeom prst="rect">
-            <a:avLst/>
-          </a:prstGeom>
-          <a:solidFill>
-            <a:srgbClr val="4472C4"/>
-          </a:solidFill>
-          <a:ln w="12700" cap="flat" cmpd="sng" algn="ctr">
-            <a:noFill/>
-            <a:prstDash val="solid"/>
-            <a:miter lim="800000"/>
-          </a:ln>
-          <a:effectLst/>
-          <a:extLst>
-            <a:ext uri="{91240B29-F687-4F45-9708-019B960494DF}">
-              <a14:hiddenLine xmlns:a14="http://schemas.microsoft.com/office/drawing/2010/main" w="12700" cap="flat" cmpd="sng" algn="ctr">
-                <a:solidFill>
-                  <a:schemeClr val="accent1">
-                    <a:shade val="15000"/>
-                  </a:schemeClr>
-                </a:solidFill>
-                <a:prstDash val="solid"/>
-                <a:miter lim="800000"/>
-              </a14:hiddenLine>
-            </a:ext>
-          </a:extLst>
-        </p:spPr>
-        <p:style>
-          <a:lnRef idx="2">
-            <a:schemeClr val="accent1">
-              <a:shade val="15000"/>
-            </a:schemeClr>
-          </a:lnRef>
-          <a:fillRef idx="1">
-            <a:schemeClr val="accent1"/>
-          </a:fillRef>
-          <a:effectRef idx="0">
-            <a:schemeClr val="accent1"/>
-          </a:effectRef>
-          <a:fontRef idx="minor">
-            <a:schemeClr val="lt1"/>
-          </a:fontRef>
-        </p:style>
-        <p:txBody>
-          <a:bodyPr rtlCol="0" anchor="ctr"/>
-          <a:lstStyle/>
-          <a:p>
-            <a:pPr algn="ctr"/>
-            <a:endParaRPr lang="en-US"/>
-          </a:p>
-        </p:txBody>
-      </p:sp>
-    </p:spTree>
-    <p:extLst>
-      <p:ext uri="{BB962C8B-B14F-4D97-AF65-F5344CB8AC3E}">
-        <p14:creationId xmlns:p14="http://schemas.microsoft.com/office/powerpoint/2010/main" val="2126892714"/>
-      </p:ext>
-    </p:extLst>
-  </p:cSld>
-  <p:clrMapOvr>
-    <a:masterClrMapping/>
-  </p:clrMapOvr>
-  <p:timing>
-    <p:tnLst>
-      <p:par>
-        <p:cTn id="1" dur="indefinite" restart="never" nodeType="tmRoot">
-          <p:childTnLst>
-            <p:seq concurrent="1" nextAc="seek">
-              <p:cTn id="2" dur="indefinite" nodeType="mainSeq">
-                <p:childTnLst>
-                  <p:par>
-                    <p:cTn id="3" fill="hold">
-                      <p:stCondLst>
-                        <p:cond delay="indefinite"/>
-                      </p:stCondLst>
-                      <p:childTnLst>
-                        <p:par>
-                          <p:cTn id="4" fill="hold">
-                            <p:stCondLst>
-                              <p:cond delay="0"/>
-                            </p:stCondLst>
-                            <p:childTnLst>
-                              <p:par>
-                                <p:cTn id="5" presetID="34" presetClass="entr" presetSubtype="0" fill="hold" grpId="0" nodeType="clickEffect">
-                                  <p:stCondLst>
-                                    <p:cond delay="0"/>
-                                  </p:stCondLst>
-                                  <p:childTnLst>
-                                    <p:set>
-                                      <p:cBhvr>
-                                        <p:cTn id="6" dur="1" fill="hold">
-                                          <p:stCondLst>
-                                            <p:cond delay="0"/>
-                                          </p:stCondLst>
-                                        </p:cTn>
-                                        <p:tgtEl>
-                                          <p:spTgt spid="6"/>
-                                        </p:tgtEl>
-                                        <p:attrNameLst>
-                                          <p:attrName>style.visibility</p:attrName>
-                                        </p:attrNameLst>
-                                      </p:cBhvr>
-                                      <p:to>
-                                        <p:strVal val="visible"/>
-                                      </p:to>
-                                    </p:set>
-                                    <p:anim from="(-#ppt_w/2)" to="(#ppt_x)" calcmode="lin" valueType="num">
-                                      <p:cBhvr>
-                                        <p:cTn id="7" dur="600" fill="hold">
-                                          <p:stCondLst>
-                                            <p:cond delay="0"/>
-                                          </p:stCondLst>
-                                        </p:cTn>
-                                        <p:tgtEl>
-                                          <p:spTgt spid="6"/>
-                                        </p:tgtEl>
-                                        <p:attrNameLst>
-                                          <p:attrName>ppt_x</p:attrName>
-                                        </p:attrNameLst>
-                                      </p:cBhvr>
-                                    </p:anim>
-                                    <p:anim from="0" to="-1.0" calcmode="lin" valueType="num">
-                                      <p:cBhvr>
-                                        <p:cTn id="8" dur="200" decel="50000" autoRev="1" fill="hold">
-                                          <p:stCondLst>
-                                            <p:cond delay="600"/>
-                                          </p:stCondLst>
-                                        </p:cTn>
-                                        <p:tgtEl>
-                                          <p:spTgt spid="6"/>
-                                        </p:tgtEl>
-                                        <p:attrNameLst>
-                                          <p:attrName>xshear</p:attrName>
-                                        </p:attrNameLst>
-                                      </p:cBhvr>
-                                    </p:anim>
-                                    <p:animScale>
-                                      <p:cBhvr>
-                                        <p:cTn id="9" dur="200" decel="100000" autoRev="1" fill="hold">
-                                          <p:stCondLst>
-                                            <p:cond delay="600"/>
-                                          </p:stCondLst>
-                                        </p:cTn>
-                                        <p:tgtEl>
-                                          <p:spTgt spid="6"/>
-                                        </p:tgtEl>
-                                      </p:cBhvr>
-                                      <p:from x="100000" y="100000"/>
-                                      <p:to x="80000" y="100000"/>
-                                    </p:animScale>
-                                    <p:anim by="(#ppt_h/3+#ppt_w*0.1)" calcmode="lin" valueType="num">
-                                      <p:cBhvr additive="sum">
-                                        <p:cTn id="10" dur="200" decel="100000" autoRev="1" fill="hold">
-                                          <p:stCondLst>
-                                            <p:cond delay="600"/>
-                                          </p:stCondLst>
-                                        </p:cTn>
-                                        <p:tgtEl>
-                                          <p:spTgt spid="6"/>
-                                        </p:tgtEl>
-                                        <p:attrNameLst>
-                                          <p:attrName>ppt_x</p:attrName>
-                                        </p:attrNameLst>
-                                      </p:cBhvr>
-                                    </p:anim>
-                                  </p:childTnLst>
-                                </p:cTn>
-                              </p:par>
-                            </p:childTnLst>
-                          </p:cTn>
-                        </p:par>
-                      </p:childTnLst>
-                    </p:cTn>
-                  </p:par>
-                  <p:par>
-                    <p:cTn id="11" fill="hold">
-                      <p:stCondLst>
-                        <p:cond delay="indefinite"/>
-                      </p:stCondLst>
-                      <p:childTnLst>
-                        <p:par>
-                          <p:cTn id="12" fill="hold">
-                            <p:stCondLst>
-                              <p:cond delay="0"/>
-                            </p:stCondLst>
-                            <p:childTnLst>
-                              <p:par>
-                                <p:cTn id="13" presetID="34" presetClass="entr" presetSubtype="0" fill="hold" grpId="0" nodeType="clickEffect">
-                                  <p:stCondLst>
-                                    <p:cond delay="0"/>
-                                  </p:stCondLst>
-                                  <p:childTnLst>
-                                    <p:set>
-                                      <p:cBhvr>
-                                        <p:cTn id="14" dur="1" fill="hold">
-                                          <p:stCondLst>
-                                            <p:cond delay="0"/>
-                                          </p:stCondLst>
-                                        </p:cTn>
-                                        <p:tgtEl>
-                                          <p:spTgt spid="8"/>
-                                        </p:tgtEl>
-                                        <p:attrNameLst>
-                                          <p:attrName>style.visibility</p:attrName>
-                                        </p:attrNameLst>
-                                      </p:cBhvr>
-                                      <p:to>
-                                        <p:strVal val="visible"/>
-                                      </p:to>
-                                    </p:set>
-                                    <p:anim from="(-#ppt_w/2)" to="(#ppt_x)" calcmode="lin" valueType="num">
-                                      <p:cBhvr>
-                                        <p:cTn id="15" dur="600" fill="hold">
-                                          <p:stCondLst>
-                                            <p:cond delay="0"/>
-                                          </p:stCondLst>
-                                        </p:cTn>
-                                        <p:tgtEl>
-                                          <p:spTgt spid="8"/>
-                                        </p:tgtEl>
-                                        <p:attrNameLst>
-                                          <p:attrName>ppt_x</p:attrName>
-                                        </p:attrNameLst>
-                                      </p:cBhvr>
-                                    </p:anim>
-                                    <p:anim from="0" to="-1.0" calcmode="lin" valueType="num">
-                                      <p:cBhvr>
-                                        <p:cTn id="16" dur="200" decel="50000" autoRev="1" fill="hold">
-                                          <p:stCondLst>
-                                            <p:cond delay="600"/>
-                                          </p:stCondLst>
-                                        </p:cTn>
-                                        <p:tgtEl>
-                                          <p:spTgt spid="8"/>
-                                        </p:tgtEl>
-                                        <p:attrNameLst>
-                                          <p:attrName>xshear</p:attrName>
-                                        </p:attrNameLst>
-                                      </p:cBhvr>
-                                    </p:anim>
-                                    <p:animScale>
-                                      <p:cBhvr>
-                                        <p:cTn id="17" dur="200" decel="100000" autoRev="1" fill="hold">
-                                          <p:stCondLst>
-                                            <p:cond delay="600"/>
-                                          </p:stCondLst>
-                                        </p:cTn>
-                                        <p:tgtEl>
-                                          <p:spTgt spid="8"/>
-                                        </p:tgtEl>
-                                      </p:cBhvr>
-                                      <p:from x="100000" y="100000"/>
-                                      <p:to x="80000" y="100000"/>
-                                    </p:animScale>
-                                    <p:anim by="(#ppt_h/3+#ppt_w*0.1)" calcmode="lin" valueType="num">
-                                      <p:cBhvr additive="sum">
-                                        <p:cTn id="18" dur="200" decel="100000" autoRev="1" fill="hold">
-                                          <p:stCondLst>
-                                            <p:cond delay="600"/>
-                                          </p:stCondLst>
-                                        </p:cTn>
-                                        <p:tgtEl>
-                                          <p:spTgt spid="8"/>
-                                        </p:tgtEl>
-                                        <p:attrNameLst>
-                                          <p:attrName>ppt_x</p:attrName>
-                                        </p:attrNameLst>
-                                      </p:cBhvr>
-                                    </p:anim>
-                                  </p:childTnLst>
-                                </p:cTn>
-                              </p:par>
-                            </p:childTnLst>
-                          </p:cTn>
-                        </p:par>
-                      </p:childTnLst>
-                    </p:cTn>
-                  </p:par>
-                  <p:par>
-                    <p:cTn id="19" fill="hold">
-                      <p:stCondLst>
-                        <p:cond delay="indefinite"/>
-                      </p:stCondLst>
-                      <p:childTnLst>
-                        <p:par>
-                          <p:cTn id="20" fill="hold">
-                            <p:stCondLst>
-                              <p:cond delay="0"/>
-                            </p:stCondLst>
-                            <p:childTnLst>
-                              <p:par>
-                                <p:cTn id="21" presetID="34" presetClass="entr" presetSubtype="0" fill="hold" grpId="0" nodeType="clickEffect">
-                                  <p:stCondLst>
-                                    <p:cond delay="0"/>
-                                  </p:stCondLst>
-                                  <p:childTnLst>
-                                    <p:set>
-                                      <p:cBhvr>
-                                        <p:cTn id="22" dur="1" fill="hold">
-                                          <p:stCondLst>
-                                            <p:cond delay="0"/>
-                                          </p:stCondLst>
-                                        </p:cTn>
-                                        <p:tgtEl>
-                                          <p:spTgt spid="10"/>
-                                        </p:tgtEl>
-                                        <p:attrNameLst>
-                                          <p:attrName>style.visibility</p:attrName>
-                                        </p:attrNameLst>
-                                      </p:cBhvr>
-                                      <p:to>
-                                        <p:strVal val="visible"/>
-                                      </p:to>
-                                    </p:set>
-                                    <p:anim from="(-#ppt_w/2)" to="(#ppt_x)" calcmode="lin" valueType="num">
-                                      <p:cBhvr>
-                                        <p:cTn id="23" dur="600" fill="hold">
-                                          <p:stCondLst>
-                                            <p:cond delay="0"/>
-                                          </p:stCondLst>
-                                        </p:cTn>
-                                        <p:tgtEl>
-                                          <p:spTgt spid="10"/>
-                                        </p:tgtEl>
-                                        <p:attrNameLst>
-                                          <p:attrName>ppt_x</p:attrName>
-                                        </p:attrNameLst>
-                                      </p:cBhvr>
-                                    </p:anim>
-                                    <p:anim from="0" to="-1.0" calcmode="lin" valueType="num">
-                                      <p:cBhvr>
-                                        <p:cTn id="24" dur="200" decel="50000" autoRev="1" fill="hold">
-                                          <p:stCondLst>
-                                            <p:cond delay="600"/>
-                                          </p:stCondLst>
-                                        </p:cTn>
-                                        <p:tgtEl>
-                                          <p:spTgt spid="10"/>
-                                        </p:tgtEl>
-                                        <p:attrNameLst>
-                                          <p:attrName>xshear</p:attrName>
-                                        </p:attrNameLst>
-                                      </p:cBhvr>
-                                    </p:anim>
-                                    <p:animScale>
-                                      <p:cBhvr>
-                                        <p:cTn id="25" dur="200" decel="100000" autoRev="1" fill="hold">
-                                          <p:stCondLst>
-                                            <p:cond delay="600"/>
-                                          </p:stCondLst>
-                                        </p:cTn>
-                                        <p:tgtEl>
-                                          <p:spTgt spid="10"/>
-                                        </p:tgtEl>
-                                      </p:cBhvr>
-                                      <p:from x="100000" y="100000"/>
-                                      <p:to x="80000" y="100000"/>
-                                    </p:animScale>
-                                    <p:anim by="(#ppt_h/3+#ppt_w*0.1)" calcmode="lin" valueType="num">
-                                      <p:cBhvr additive="sum">
-                                        <p:cTn id="26" dur="200" decel="100000" autoRev="1" fill="hold">
-                                          <p:stCondLst>
-                                            <p:cond delay="600"/>
-                                          </p:stCondLst>
-                                        </p:cTn>
-                                        <p:tgtEl>
-                                          <p:spTgt spid="10"/>
-                                        </p:tgtEl>
-                                        <p:attrNameLst>
-                                          <p:attrName>ppt_x</p:attrName>
-                                        </p:attrNameLst>
-                                      </p:cBhvr>
-                                    </p:anim>
-                                  </p:childTnLst>
-                                </p:cTn>
-                              </p:par>
-                            </p:childTnLst>
-                          </p:cTn>
-                        </p:par>
-                      </p:childTnLst>
-                    </p:cTn>
-                  </p:par>
-                </p:childTnLst>
-              </p:cTn>
-              <p:prevCondLst>
-                <p:cond evt="onPrev" delay="0">
-                  <p:tgtEl>
-                    <p:sldTgt/>
-                  </p:tgtEl>
-                </p:cond>
-              </p:prevCondLst>
-              <p:nextCondLst>
-                <p:cond evt="onNext" delay="0">
-                  <p:tgtEl>
-                    <p:sldTgt/>
-                  </p:tgtEl>
-                </p:cond>
-              </p:nextCondLst>
-            </p:seq>
-          </p:childTnLst>
-        </p:cTn>
-      </p:par>
-    </p:tnLst>
-    <p:bldLst>
-      <p:bldP spid="6" grpId="0"/>
-      <p:bldP spid="8" grpId="0"/>
-      <p:bldP spid="10" grpId="0"/>
-    </p:bldLst>
-  </p:timing>
-</p:sld>
-</file>
-
-<file path=ppt/slides/slide24.xml><?xml version="1.0" encoding="utf-8"?>
-<p:sld xmlns:a="http://schemas.openxmlformats.org/drawingml/2006/main" xmlns:r="http://schemas.openxmlformats.org/officeDocument/2006/relationships" xmlns:p="http://schemas.openxmlformats.org/presentationml/2006/main">
-  <p:cSld>
-    <p:spTree>
-      <p:nvGrpSpPr>
-        <p:cNvPr id="1" name=""/>
-        <p:cNvGrpSpPr/>
-        <p:nvPr/>
-      </p:nvGrpSpPr>
-      <p:grpSpPr>
-        <a:xfrm>
-          <a:off x="0" y="0"/>
-          <a:ext cx="0" cy="0"/>
-          <a:chOff x="0" y="0"/>
-          <a:chExt cx="0" cy="0"/>
-        </a:xfrm>
-      </p:grpSpPr>
-      <p:sp>
-        <p:nvSpPr>
-          <p:cNvPr id="2" name="Title 1">
-            <a:extLst>
-              <a:ext uri="{FF2B5EF4-FFF2-40B4-BE49-F238E27FC236}">
-                <a16:creationId xmlns:a16="http://schemas.microsoft.com/office/drawing/2014/main" id="{C08D30B1-1864-30EF-7EAB-9BEE656C0012}"/>
-              </a:ext>
-            </a:extLst>
-          </p:cNvPr>
-          <p:cNvSpPr>
-            <a:spLocks noGrp="1"/>
-          </p:cNvSpPr>
-          <p:nvPr>
-            <p:ph type="title"/>
-          </p:nvPr>
-        </p:nvSpPr>
-        <p:spPr/>
-        <p:txBody>
-          <a:bodyPr>
-            <a:noAutofit/>
-          </a:bodyPr>
-          <a:lstStyle/>
-          <a:p>
-            <a:r>
-              <a:rPr lang="en-US">
-                <a:solidFill>
-                  <a:srgbClr val="1F3864"/>
-                </a:solidFill>
-              </a:rPr>
-              <a:t>Why probability?</a:t>
-            </a:r>
-          </a:p>
-        </p:txBody>
-      </p:sp>
-      <p:sp>
-        <p:nvSpPr>
-          <p:cNvPr id="4" name="Slide Number Placeholder 3">
-            <a:extLst>
-              <a:ext uri="{FF2B5EF4-FFF2-40B4-BE49-F238E27FC236}">
-                <a16:creationId xmlns:a16="http://schemas.microsoft.com/office/drawing/2014/main" id="{3F875068-D051-44AE-498E-1BEBEDE3A7C8}"/>
-              </a:ext>
-            </a:extLst>
-          </p:cNvPr>
-          <p:cNvSpPr>
-            <a:spLocks noGrp="1"/>
-          </p:cNvSpPr>
-          <p:nvPr>
-            <p:ph type="sldNum" sz="quarter" idx="12"/>
-          </p:nvPr>
-        </p:nvSpPr>
-        <p:spPr/>
-        <p:txBody>
-          <a:bodyPr/>
-          <a:lstStyle/>
-          <a:p>
-            <a:fld id="{A80A81DD-F10A-4B1C-963A-0ABBB4865886}" type="slidenum">
-              <a:rPr lang="en-US" sz="1600" smtClean="0"/>
-              <a:t>24</a:t>
-            </a:fld>
-            <a:endParaRPr lang="en-US" sz="1600"/>
-          </a:p>
-        </p:txBody>
-      </p:sp>
-      <p:sp>
-        <p:nvSpPr>
-          <p:cNvPr id="3" name="Title rule">
-            <a:extLst>
-              <a:ext uri="{FF2B5EF4-FFF2-40B4-BE49-F238E27FC236}">
-                <a16:creationId xmlns:a16="http://schemas.microsoft.com/office/drawing/2014/main" id="{30656AA8-9645-F028-C769-A313710853CC}"/>
-              </a:ext>
-            </a:extLst>
-          </p:cNvPr>
-          <p:cNvSpPr/>
-          <p:nvPr/>
-        </p:nvSpPr>
-        <p:spPr>
-          <a:xfrm>
-            <a:off x="838200" y="1600200"/>
-            <a:ext cx="10515600" cy="38100"/>
-          </a:xfrm>
-          <a:prstGeom prst="rect">
-            <a:avLst/>
-          </a:prstGeom>
-          <a:solidFill>
-            <a:srgbClr val="4472C4"/>
-          </a:solidFill>
-          <a:ln w="12700" cap="flat" cmpd="sng" algn="ctr">
-            <a:noFill/>
-            <a:prstDash val="solid"/>
-            <a:miter lim="800000"/>
-          </a:ln>
-          <a:effectLst/>
-          <a:extLst>
-            <a:ext uri="{91240B29-F687-4F45-9708-019B960494DF}">
-              <a14:hiddenLine xmlns:a14="http://schemas.microsoft.com/office/drawing/2010/main" w="12700" cap="flat" cmpd="sng" algn="ctr">
-                <a:solidFill>
-                  <a:schemeClr val="accent1">
-                    <a:shade val="15000"/>
-                  </a:schemeClr>
-                </a:solidFill>
-                <a:prstDash val="solid"/>
-                <a:miter lim="800000"/>
-              </a14:hiddenLine>
-            </a:ext>
-          </a:extLst>
-        </p:spPr>
-        <p:style>
-          <a:lnRef idx="2">
-            <a:schemeClr val="accent1">
-              <a:shade val="15000"/>
-            </a:schemeClr>
-          </a:lnRef>
-          <a:fillRef idx="1">
-            <a:schemeClr val="accent1"/>
-          </a:fillRef>
-          <a:effectRef idx="0">
-            <a:schemeClr val="accent1"/>
-          </a:effectRef>
-          <a:fontRef idx="minor">
-            <a:schemeClr val="lt1"/>
-          </a:fontRef>
-        </p:style>
-        <p:txBody>
-          <a:bodyPr rtlCol="0" anchor="ctr"/>
-          <a:lstStyle/>
-          <a:p>
-            <a:pPr algn="ctr"/>
-            <a:endParaRPr lang="en-US"/>
-          </a:p>
-        </p:txBody>
-      </p:sp>
-      <p:sp>
-        <p:nvSpPr>
-          <p:cNvPr id="8" name="Context">
-            <a:extLst>
-              <a:ext uri="{FF2B5EF4-FFF2-40B4-BE49-F238E27FC236}">
-                <a16:creationId xmlns:a16="http://schemas.microsoft.com/office/drawing/2014/main" id="{71E3EA8C-31B4-DAD4-BC4A-65D72E59AD46}"/>
-              </a:ext>
-            </a:extLst>
-          </p:cNvPr>
-          <p:cNvSpPr txBox="1"/>
-          <p:nvPr/>
-        </p:nvSpPr>
-        <p:spPr>
-          <a:xfrm>
-            <a:off x="762000" y="1879600"/>
-            <a:ext cx="10668000" cy="381000"/>
-          </a:xfrm>
-          <a:prstGeom prst="rect">
-            <a:avLst/>
-          </a:prstGeom>
-          <a:noFill/>
-        </p:spPr>
-        <p:txBody>
-          <a:bodyPr vert="horz" wrap="square" rtlCol="0">
-            <a:spAutoFit/>
-          </a:bodyPr>
-          <a:lstStyle/>
-          <a:p>
-            <a:pPr>
-              <a:spcAft>
-                <a:spcPts val="200"/>
-              </a:spcAft>
-            </a:pPr>
-            <a:r>
-              <a:rPr lang="en-US">
-                <a:solidFill>
-                  <a:srgbClr val="000000"/>
-                </a:solidFill>
-                <a:latin typeface="Calibri" panose="020F0502020204030204" pitchFamily="34" charset="0"/>
-              </a:rPr>
-              <a:t>The margin of error said: about 95% of samples land within 2 SE of μ.</a:t>
-            </a:r>
-          </a:p>
-        </p:txBody>
-      </p:sp>
-      <p:sp>
-        <p:nvSpPr>
-          <p:cNvPr id="10" name="Question">
-            <a:extLst>
-              <a:ext uri="{FF2B5EF4-FFF2-40B4-BE49-F238E27FC236}">
-                <a16:creationId xmlns:a16="http://schemas.microsoft.com/office/drawing/2014/main" id="{B31E395F-B84E-D1E9-D22A-222467FC4105}"/>
-              </a:ext>
-            </a:extLst>
-          </p:cNvPr>
-          <p:cNvSpPr txBox="1"/>
-          <p:nvPr/>
-        </p:nvSpPr>
-        <p:spPr>
-          <a:xfrm>
-            <a:off x="762000" y="2286000"/>
-            <a:ext cx="10668000" cy="369332"/>
-          </a:xfrm>
-          <a:prstGeom prst="rect">
-            <a:avLst/>
-          </a:prstGeom>
-          <a:noFill/>
-        </p:spPr>
-        <p:txBody>
-          <a:bodyPr vert="horz" wrap="square" rtlCol="0">
-            <a:spAutoFit/>
-          </a:bodyPr>
-          <a:lstStyle/>
-          <a:p>
-            <a:pPr>
-              <a:spcAft>
-                <a:spcPts val="200"/>
-              </a:spcAft>
-            </a:pPr>
-            <a:r>
-              <a:rPr lang="en-US" b="1">
-                <a:solidFill>
-                  <a:srgbClr val="C00000"/>
-                </a:solidFill>
-                <a:latin typeface="Calibri" panose="020F0502020204030204" pitchFamily="34" charset="0"/>
-              </a:rPr>
-              <a:t>But we only ever take one sample. So what does "95%" mean?</a:t>
-            </a:r>
-          </a:p>
-        </p:txBody>
-      </p:sp>
-      <p:sp>
-        <p:nvSpPr>
-          <p:cNvPr id="11" name="Result">
-            <a:extLst>
-              <a:ext uri="{FF2B5EF4-FFF2-40B4-BE49-F238E27FC236}">
-                <a16:creationId xmlns:a16="http://schemas.microsoft.com/office/drawing/2014/main" id="{5A70F68E-0D93-07B8-82B2-4D8F2F681D0D}"/>
-              </a:ext>
-            </a:extLst>
-          </p:cNvPr>
-          <p:cNvSpPr/>
-          <p:nvPr/>
-        </p:nvSpPr>
-        <p:spPr>
-          <a:xfrm>
-            <a:off x="762000" y="2807732"/>
-            <a:ext cx="10668000" cy="784324"/>
-          </a:xfrm>
-          <a:prstGeom prst="roundRect">
-            <a:avLst>
-              <a:gd name="adj" fmla="val 4000"/>
-            </a:avLst>
-          </a:prstGeom>
-          <a:solidFill>
-            <a:srgbClr val="F2F6FC"/>
-          </a:solidFill>
-          <a:ln w="15875">
-            <a:solidFill>
-              <a:srgbClr val="4472C4"/>
-            </a:solidFill>
-          </a:ln>
-        </p:spPr>
-        <p:style>
-          <a:lnRef idx="2">
-            <a:schemeClr val="accent1">
-              <a:shade val="15000"/>
-            </a:schemeClr>
-          </a:lnRef>
-          <a:fillRef idx="1">
-            <a:schemeClr val="accent1"/>
-          </a:fillRef>
-          <a:effectRef idx="0">
-            <a:schemeClr val="accent1"/>
-          </a:effectRef>
-          <a:fontRef idx="minor">
-            <a:schemeClr val="lt1"/>
-          </a:fontRef>
-        </p:style>
-        <p:txBody>
-          <a:bodyPr wrap="square" lIns="152400" tIns="76200" rIns="152400" bIns="76200" rtlCol="0" anchor="ctr">
-            <a:spAutoFit/>
-          </a:bodyPr>
-          <a:lstStyle/>
-          <a:p>
-            <a:r>
-              <a:rPr lang="en-US" sz="2000" b="1" dirty="0">
-                <a:solidFill>
-                  <a:srgbClr val="C00000"/>
-                </a:solidFill>
-                <a:latin typeface="Calibri" panose="020F0502020204030204" pitchFamily="34" charset="0"/>
-              </a:rPr>
-              <a:t>It describes the probability over many repeated samples, about 95% would land that close</a:t>
-            </a:r>
-          </a:p>
-          <a:p>
-            <a:r>
-              <a:rPr lang="en-US" b="1" dirty="0">
-                <a:solidFill>
-                  <a:srgbClr val="C00000"/>
-                </a:solidFill>
-                <a:latin typeface="Calibri" panose="020F0502020204030204" pitchFamily="34" charset="0"/>
-              </a:rPr>
-              <a:t>A statement about repeated sampling is a statement about probability</a:t>
-            </a:r>
-          </a:p>
-        </p:txBody>
-      </p:sp>
-    </p:spTree>
-    <p:extLst>
-      <p:ext uri="{BB962C8B-B14F-4D97-AF65-F5344CB8AC3E}">
-        <p14:creationId xmlns:p14="http://schemas.microsoft.com/office/powerpoint/2010/main" val="893199840"/>
-      </p:ext>
-    </p:extLst>
-  </p:cSld>
-  <p:clrMapOvr>
-    <a:masterClrMapping/>
-  </p:clrMapOvr>
-  <p:timing>
-    <p:tnLst>
-      <p:par>
-        <p:cTn id="1" dur="indefinite" restart="never" nodeType="tmRoot">
-          <p:childTnLst>
-            <p:seq concurrent="1" nextAc="seek">
-              <p:cTn id="2" dur="indefinite" nodeType="mainSeq">
-                <p:childTnLst>
-                  <p:par>
-                    <p:cTn id="3" fill="hold">
-                      <p:stCondLst>
-                        <p:cond delay="indefinite"/>
-                      </p:stCondLst>
-                      <p:childTnLst>
-                        <p:par>
-                          <p:cTn id="4" fill="hold">
-                            <p:stCondLst>
-                              <p:cond delay="0"/>
-                            </p:stCondLst>
-                            <p:childTnLst>
-                              <p:par>
-                                <p:cTn id="5" presetID="1" presetClass="entr" presetSubtype="0" fill="hold" grpId="0" nodeType="clickEffect">
-                                  <p:stCondLst>
-                                    <p:cond delay="0"/>
-                                  </p:stCondLst>
-                                  <p:childTnLst>
-                                    <p:set>
-                                      <p:cBhvr>
-                                        <p:cTn id="6" dur="1" fill="hold">
-                                          <p:stCondLst>
-                                            <p:cond delay="0"/>
-                                          </p:stCondLst>
-                                        </p:cTn>
-                                        <p:tgtEl>
-                                          <p:spTgt spid="11"/>
-                                        </p:tgtEl>
-                                        <p:attrNameLst>
-                                          <p:attrName>style.visibility</p:attrName>
-                                        </p:attrNameLst>
-                                      </p:cBhvr>
-                                      <p:to>
-                                        <p:strVal val="visible"/>
-                                      </p:to>
-                                    </p:set>
-                                  </p:childTnLst>
-                                </p:cTn>
-                              </p:par>
-                            </p:childTnLst>
-                          </p:cTn>
-                        </p:par>
-                      </p:childTnLst>
-                    </p:cTn>
-                  </p:par>
-                </p:childTnLst>
-              </p:cTn>
-              <p:prevCondLst>
-                <p:cond evt="onPrev" delay="0">
-                  <p:tgtEl>
-                    <p:sldTgt/>
-                  </p:tgtEl>
-                </p:cond>
-              </p:prevCondLst>
-              <p:nextCondLst>
-                <p:cond evt="onNext" delay="0">
-                  <p:tgtEl>
-                    <p:sldTgt/>
-                  </p:tgtEl>
-                </p:cond>
-              </p:nextCondLst>
-            </p:seq>
-          </p:childTnLst>
-        </p:cTn>
-      </p:par>
-    </p:tnLst>
-    <p:bldLst>
-      <p:bldP spid="11" grpId="0" animBg="1"/>
-    </p:bldLst>
-  </p:timing>
-</p:sld>
-</file>
-
-<file path=ppt/slides/slide25.xml><?xml version="1.0" encoding="utf-8"?>
-<p:sld xmlns:a="http://schemas.openxmlformats.org/drawingml/2006/main" xmlns:r="http://schemas.openxmlformats.org/officeDocument/2006/relationships" xmlns:p="http://schemas.openxmlformats.org/presentationml/2006/main">
-  <p:cSld>
-    <p:spTree>
-      <p:nvGrpSpPr>
-        <p:cNvPr id="1" name=""/>
-        <p:cNvGrpSpPr/>
-        <p:nvPr/>
-      </p:nvGrpSpPr>
-      <p:grpSpPr>
-        <a:xfrm>
-          <a:off x="0" y="0"/>
-          <a:ext cx="0" cy="0"/>
-          <a:chOff x="0" y="0"/>
-          <a:chExt cx="0" cy="0"/>
-        </a:xfrm>
-      </p:grpSpPr>
-      <p:sp>
-        <p:nvSpPr>
-          <p:cNvPr id="2" name="Title 1">
-            <a:extLst>
-              <a:ext uri="{FF2B5EF4-FFF2-40B4-BE49-F238E27FC236}">
-                <a16:creationId xmlns:a16="http://schemas.microsoft.com/office/drawing/2014/main" id="{D1E825F3-CA5C-D321-A12F-235D7E6C102E}"/>
-              </a:ext>
-            </a:extLst>
-          </p:cNvPr>
-          <p:cNvSpPr>
-            <a:spLocks noGrp="1"/>
-          </p:cNvSpPr>
-          <p:nvPr>
-            <p:ph type="title"/>
-          </p:nvPr>
-        </p:nvSpPr>
-        <p:spPr/>
-        <p:txBody>
-          <a:bodyPr>
-            <a:noAutofit/>
-          </a:bodyPr>
-          <a:lstStyle/>
-          <a:p>
-            <a:r>
-              <a:rPr lang="en-US">
-                <a:solidFill>
-                  <a:srgbClr val="1F3864"/>
-                </a:solidFill>
-              </a:rPr>
-              <a:t>Probability</a:t>
-            </a:r>
-          </a:p>
-        </p:txBody>
-      </p:sp>
-      <p:sp>
-        <p:nvSpPr>
-          <p:cNvPr id="4" name="Slide Number Placeholder 3">
-            <a:extLst>
-              <a:ext uri="{FF2B5EF4-FFF2-40B4-BE49-F238E27FC236}">
-                <a16:creationId xmlns:a16="http://schemas.microsoft.com/office/drawing/2014/main" id="{632F5803-1B77-5AE0-EEB8-17B8E3F9722A}"/>
-              </a:ext>
-            </a:extLst>
-          </p:cNvPr>
-          <p:cNvSpPr>
-            <a:spLocks noGrp="1"/>
-          </p:cNvSpPr>
-          <p:nvPr>
-            <p:ph type="sldNum" sz="quarter" idx="12"/>
-          </p:nvPr>
-        </p:nvSpPr>
-        <p:spPr/>
-        <p:txBody>
-          <a:bodyPr/>
-          <a:lstStyle/>
-          <a:p>
-            <a:fld id="{A80A81DD-F10A-4B1C-963A-0ABBB4865886}" type="slidenum">
-              <a:rPr lang="en-US" sz="1600" smtClean="0"/>
-              <a:t>25</a:t>
-            </a:fld>
-            <a:endParaRPr lang="en-US" sz="1600"/>
-          </a:p>
-        </p:txBody>
-      </p:sp>
-      <p:sp>
-        <p:nvSpPr>
-          <p:cNvPr id="5" name="TextBox 4">
-            <a:extLst>
-              <a:ext uri="{FF2B5EF4-FFF2-40B4-BE49-F238E27FC236}">
-                <a16:creationId xmlns:a16="http://schemas.microsoft.com/office/drawing/2014/main" id="{F2C3E119-33DB-B84A-C9CB-1DA41099D1A1}"/>
-              </a:ext>
-            </a:extLst>
-          </p:cNvPr>
-          <p:cNvSpPr txBox="1"/>
-          <p:nvPr/>
-        </p:nvSpPr>
-        <p:spPr>
-          <a:xfrm>
-            <a:off x="762000" y="1841500"/>
-            <a:ext cx="3175000" cy="345440"/>
-          </a:xfrm>
-          <a:prstGeom prst="rect">
-            <a:avLst/>
-          </a:prstGeom>
-          <a:noFill/>
-        </p:spPr>
-        <p:txBody>
-          <a:bodyPr vert="horz" wrap="square" rtlCol="0">
-            <a:spAutoFit/>
-          </a:bodyPr>
-          <a:lstStyle/>
-          <a:p>
-            <a:r>
-              <a:rPr lang="en-US" sz="1600" b="1">
-                <a:solidFill>
-                  <a:srgbClr val="C00000"/>
-                </a:solidFill>
-              </a:rPr>
-              <a:t>probability</a:t>
-            </a:r>
-          </a:p>
-        </p:txBody>
-      </p:sp>
-      <p:sp>
-        <p:nvSpPr>
-          <p:cNvPr id="6" name="TextBox 5">
-            <a:extLst>
-              <a:ext uri="{FF2B5EF4-FFF2-40B4-BE49-F238E27FC236}">
-                <a16:creationId xmlns:a16="http://schemas.microsoft.com/office/drawing/2014/main" id="{377D380C-8635-8A53-300D-33D0068157E3}"/>
-              </a:ext>
-            </a:extLst>
-          </p:cNvPr>
-          <p:cNvSpPr txBox="1"/>
-          <p:nvPr/>
-        </p:nvSpPr>
-        <p:spPr>
-          <a:xfrm>
-            <a:off x="4038600" y="1841499"/>
-            <a:ext cx="7391400" cy="584775"/>
-          </a:xfrm>
-          <a:prstGeom prst="rect">
-            <a:avLst/>
-          </a:prstGeom>
-          <a:noFill/>
-        </p:spPr>
-        <p:txBody>
-          <a:bodyPr vert="horz" wrap="square" rtlCol="0">
-            <a:spAutoFit/>
-          </a:bodyPr>
-          <a:lstStyle/>
-          <a:p>
-            <a:r>
-              <a:rPr lang="en-US" sz="1600">
-                <a:solidFill>
-                  <a:srgbClr val="000000"/>
-                </a:solidFill>
-              </a:rPr>
-              <a:t>the proportion of times an outcome would occur over a very long series of repetitions; always between 0 and 1</a:t>
-            </a:r>
-            <a:endParaRPr lang="en-US" sz="1600" i="1">
-              <a:solidFill>
-                <a:srgbClr val="595959"/>
-              </a:solidFill>
-            </a:endParaRPr>
-          </a:p>
-        </p:txBody>
-      </p:sp>
-      <p:sp>
-        <p:nvSpPr>
-          <p:cNvPr id="3" name="Title rule">
-            <a:extLst>
-              <a:ext uri="{FF2B5EF4-FFF2-40B4-BE49-F238E27FC236}">
-                <a16:creationId xmlns:a16="http://schemas.microsoft.com/office/drawing/2014/main" id="{784C6B91-DD86-0BA1-4A71-C454C38471E5}"/>
-              </a:ext>
-            </a:extLst>
-          </p:cNvPr>
-          <p:cNvSpPr/>
-          <p:nvPr/>
-        </p:nvSpPr>
-        <p:spPr>
-          <a:xfrm>
-            <a:off x="838200" y="1600200"/>
-            <a:ext cx="10515600" cy="38100"/>
-          </a:xfrm>
-          <a:prstGeom prst="rect">
-            <a:avLst/>
-          </a:prstGeom>
-          <a:solidFill>
-            <a:srgbClr val="4472C4"/>
-          </a:solidFill>
-          <a:ln w="12700" cap="flat" cmpd="sng" algn="ctr">
-            <a:noFill/>
-            <a:prstDash val="solid"/>
-            <a:miter lim="800000"/>
-          </a:ln>
-          <a:effectLst/>
-          <a:extLst>
-            <a:ext uri="{91240B29-F687-4F45-9708-019B960494DF}">
-              <a14:hiddenLine xmlns:a14="http://schemas.microsoft.com/office/drawing/2010/main" w="12700" cap="flat" cmpd="sng" algn="ctr">
-                <a:solidFill>
-                  <a:schemeClr val="accent1">
-                    <a:shade val="15000"/>
-                  </a:schemeClr>
-                </a:solidFill>
-                <a:prstDash val="solid"/>
-                <a:miter lim="800000"/>
-              </a14:hiddenLine>
-            </a:ext>
-          </a:extLst>
-        </p:spPr>
-        <p:style>
-          <a:lnRef idx="2">
-            <a:schemeClr val="accent1">
-              <a:shade val="15000"/>
-            </a:schemeClr>
-          </a:lnRef>
-          <a:fillRef idx="1">
-            <a:schemeClr val="accent1"/>
-          </a:fillRef>
-          <a:effectRef idx="0">
-            <a:schemeClr val="accent1"/>
-          </a:effectRef>
-          <a:fontRef idx="minor">
-            <a:schemeClr val="lt1"/>
-          </a:fontRef>
-        </p:style>
-        <p:txBody>
-          <a:bodyPr rtlCol="0" anchor="ctr"/>
-          <a:lstStyle/>
-          <a:p>
-            <a:pPr algn="ctr"/>
-            <a:endParaRPr lang="en-US"/>
-          </a:p>
-        </p:txBody>
-      </p:sp>
-      <p:sp>
-        <p:nvSpPr>
-          <p:cNvPr id="7" name="Result">
-            <a:extLst>
-              <a:ext uri="{FF2B5EF4-FFF2-40B4-BE49-F238E27FC236}">
-                <a16:creationId xmlns:a16="http://schemas.microsoft.com/office/drawing/2014/main" id="{572E4A4A-3BD5-CF24-E6F1-9A1E4EB1A29A}"/>
-              </a:ext>
-            </a:extLst>
-          </p:cNvPr>
-          <p:cNvSpPr/>
-          <p:nvPr/>
-        </p:nvSpPr>
-        <p:spPr>
-          <a:xfrm>
-            <a:off x="762000" y="5181600"/>
-            <a:ext cx="10668000" cy="721578"/>
-          </a:xfrm>
-          <a:prstGeom prst="roundRect">
-            <a:avLst>
-              <a:gd name="adj" fmla="val 4000"/>
-            </a:avLst>
-          </a:prstGeom>
-          <a:solidFill>
-            <a:srgbClr val="F2F6FC"/>
-          </a:solidFill>
-          <a:ln w="15875">
-            <a:solidFill>
-              <a:srgbClr val="4472C4"/>
-            </a:solidFill>
-          </a:ln>
-        </p:spPr>
-        <p:style>
-          <a:lnRef idx="2">
-            <a:schemeClr val="accent1">
-              <a:shade val="15000"/>
-            </a:schemeClr>
-          </a:lnRef>
-          <a:fillRef idx="1">
-            <a:schemeClr val="accent1"/>
-          </a:fillRef>
-          <a:effectRef idx="0">
-            <a:schemeClr val="accent1"/>
-          </a:effectRef>
-          <a:fontRef idx="minor">
-            <a:schemeClr val="lt1"/>
-          </a:fontRef>
-        </p:style>
-        <p:txBody>
-          <a:bodyPr wrap="square" lIns="152400" tIns="76200" rIns="152400" bIns="76200" rtlCol="0" anchor="ctr">
-            <a:spAutoFit/>
-          </a:bodyPr>
-          <a:lstStyle/>
-          <a:p>
-            <a:r>
-              <a:rPr lang="en-US" b="1">
-                <a:solidFill>
-                  <a:srgbClr val="C00000"/>
-                </a:solidFill>
-                <a:latin typeface="Calibri" panose="020F0502020204030204" pitchFamily="34" charset="0"/>
-              </a:rPr>
-              <a:t>The law of large numbers: over many repetitions, the proportion settles on the probability</a:t>
-            </a:r>
-          </a:p>
-          <a:p>
-            <a:r>
-              <a:rPr lang="en-US" b="1">
-                <a:solidFill>
-                  <a:srgbClr val="C00000"/>
-                </a:solidFill>
-                <a:latin typeface="Calibri" panose="020F0502020204030204" pitchFamily="34" charset="0"/>
-              </a:rPr>
-              <a:t>Karl Pearson tossed a coin 24,000 times: 12,012 heads, a proportion of 0.5005</a:t>
-            </a:r>
-          </a:p>
-        </p:txBody>
-      </p:sp>
-      <p:pic>
-        <p:nvPicPr>
-          <p:cNvPr id="9" name="l13_lln.png">
-            <a:extLst>
-              <a:ext uri="{FF2B5EF4-FFF2-40B4-BE49-F238E27FC236}">
-                <a16:creationId xmlns:a16="http://schemas.microsoft.com/office/drawing/2014/main" id="{92608EA9-B24C-54D9-F2CD-F434CFD5D7D8}"/>
-              </a:ext>
-            </a:extLst>
-          </p:cNvPr>
-          <p:cNvPicPr>
-            <a:picLocks/>
-          </p:cNvPicPr>
-          <p:nvPr/>
-        </p:nvPicPr>
-        <p:blipFill>
-          <a:blip r:embed="rId2">
-            <a:extLst>
-              <a:ext uri="{28A0092B-C50C-407E-A947-70E740481C1C}">
-                <a14:useLocalDpi xmlns:a14="http://schemas.microsoft.com/office/drawing/2010/main" val="0"/>
-              </a:ext>
-            </a:extLst>
-          </a:blip>
-          <a:stretch>
-            <a:fillRect/>
-          </a:stretch>
-        </p:blipFill>
-        <p:spPr>
-          <a:xfrm>
-            <a:off x="762000" y="2540000"/>
-            <a:ext cx="10668000" cy="2540000"/>
-          </a:xfrm>
-          <a:prstGeom prst="rect">
-            <a:avLst/>
-          </a:prstGeom>
-        </p:spPr>
-      </p:pic>
-    </p:spTree>
-    <p:extLst>
-      <p:ext uri="{BB962C8B-B14F-4D97-AF65-F5344CB8AC3E}">
-        <p14:creationId xmlns:p14="http://schemas.microsoft.com/office/powerpoint/2010/main" val="275945131"/>
-      </p:ext>
-    </p:extLst>
-  </p:cSld>
-  <p:clrMapOvr>
-    <a:masterClrMapping/>
-  </p:clrMapOvr>
-  <p:timing>
-    <p:tnLst>
-      <p:par>
-        <p:cTn id="1" dur="indefinite" restart="never" nodeType="tmRoot">
-          <p:childTnLst>
-            <p:seq concurrent="1" nextAc="seek">
-              <p:cTn id="2" dur="indefinite" nodeType="mainSeq">
-                <p:childTnLst>
-                  <p:par>
-                    <p:cTn id="3" fill="hold">
-                      <p:stCondLst>
-                        <p:cond delay="indefinite"/>
-                      </p:stCondLst>
-                      <p:childTnLst>
-                        <p:par>
-                          <p:cTn id="4" fill="hold">
-                            <p:stCondLst>
-                              <p:cond delay="0"/>
-                            </p:stCondLst>
-                            <p:childTnLst>
-                              <p:par>
-                                <p:cTn id="5" presetID="34" presetClass="entr" presetSubtype="0" fill="hold" grpId="0" nodeType="clickEffect">
-                                  <p:stCondLst>
-                                    <p:cond delay="0"/>
-                                  </p:stCondLst>
-                                  <p:childTnLst>
-                                    <p:set>
-                                      <p:cBhvr>
-                                        <p:cTn id="6" dur="1" fill="hold">
-                                          <p:stCondLst>
-                                            <p:cond delay="0"/>
-                                          </p:stCondLst>
-                                        </p:cTn>
-                                        <p:tgtEl>
-                                          <p:spTgt spid="6"/>
-                                        </p:tgtEl>
-                                        <p:attrNameLst>
-                                          <p:attrName>style.visibility</p:attrName>
-                                        </p:attrNameLst>
-                                      </p:cBhvr>
-                                      <p:to>
-                                        <p:strVal val="visible"/>
-                                      </p:to>
-                                    </p:set>
-                                    <p:anim from="(-#ppt_w/2)" to="(#ppt_x)" calcmode="lin" valueType="num">
-                                      <p:cBhvr>
-                                        <p:cTn id="7" dur="600" fill="hold">
-                                          <p:stCondLst>
-                                            <p:cond delay="0"/>
-                                          </p:stCondLst>
-                                        </p:cTn>
-                                        <p:tgtEl>
-                                          <p:spTgt spid="6"/>
-                                        </p:tgtEl>
-                                        <p:attrNameLst>
-                                          <p:attrName>ppt_x</p:attrName>
-                                        </p:attrNameLst>
-                                      </p:cBhvr>
-                                    </p:anim>
-                                    <p:anim from="0" to="-1.0" calcmode="lin" valueType="num">
-                                      <p:cBhvr>
-                                        <p:cTn id="8" dur="200" decel="50000" autoRev="1" fill="hold">
-                                          <p:stCondLst>
-                                            <p:cond delay="600"/>
-                                          </p:stCondLst>
-                                        </p:cTn>
-                                        <p:tgtEl>
-                                          <p:spTgt spid="6"/>
-                                        </p:tgtEl>
-                                        <p:attrNameLst>
-                                          <p:attrName>xshear</p:attrName>
-                                        </p:attrNameLst>
-                                      </p:cBhvr>
-                                    </p:anim>
-                                    <p:animScale>
-                                      <p:cBhvr>
-                                        <p:cTn id="9" dur="200" decel="100000" autoRev="1" fill="hold">
-                                          <p:stCondLst>
-                                            <p:cond delay="600"/>
-                                          </p:stCondLst>
-                                        </p:cTn>
-                                        <p:tgtEl>
-                                          <p:spTgt spid="6"/>
-                                        </p:tgtEl>
-                                      </p:cBhvr>
-                                      <p:from x="100000" y="100000"/>
-                                      <p:to x="80000" y="100000"/>
-                                    </p:animScale>
-                                    <p:anim by="(#ppt_h/3+#ppt_w*0.1)" calcmode="lin" valueType="num">
-                                      <p:cBhvr additive="sum">
-                                        <p:cTn id="10" dur="200" decel="100000" autoRev="1" fill="hold">
-                                          <p:stCondLst>
-                                            <p:cond delay="600"/>
-                                          </p:stCondLst>
-                                        </p:cTn>
-                                        <p:tgtEl>
-                                          <p:spTgt spid="6"/>
-                                        </p:tgtEl>
-                                        <p:attrNameLst>
-                                          <p:attrName>ppt_x</p:attrName>
-                                        </p:attrNameLst>
-                                      </p:cBhvr>
-                                    </p:anim>
-                                  </p:childTnLst>
-                                </p:cTn>
-                              </p:par>
-                            </p:childTnLst>
-                          </p:cTn>
-                        </p:par>
-                      </p:childTnLst>
-                    </p:cTn>
-                  </p:par>
-                  <p:par>
-                    <p:cTn id="11" fill="hold">
-                      <p:stCondLst>
-                        <p:cond delay="indefinite"/>
-                      </p:stCondLst>
-                      <p:childTnLst>
-                        <p:par>
-                          <p:cTn id="12" fill="hold">
-                            <p:stCondLst>
-                              <p:cond delay="0"/>
-                            </p:stCondLst>
-                            <p:childTnLst>
-                              <p:par>
-                                <p:cTn id="13" presetID="1" presetClass="entr" presetSubtype="0" fill="hold" grpId="0" nodeType="clickEffect">
-                                  <p:stCondLst>
-                                    <p:cond delay="0"/>
-                                  </p:stCondLst>
-                                  <p:childTnLst>
-                                    <p:set>
-                                      <p:cBhvr>
-                                        <p:cTn id="14" dur="1" fill="hold">
-                                          <p:stCondLst>
-                                            <p:cond delay="0"/>
-                                          </p:stCondLst>
-                                        </p:cTn>
-                                        <p:tgtEl>
-                                          <p:spTgt spid="7"/>
-                                        </p:tgtEl>
-                                        <p:attrNameLst>
-                                          <p:attrName>style.visibility</p:attrName>
-                                        </p:attrNameLst>
-                                      </p:cBhvr>
-                                      <p:to>
-                                        <p:strVal val="visible"/>
-                                      </p:to>
-                                    </p:set>
-                                  </p:childTnLst>
-                                </p:cTn>
-                              </p:par>
-                            </p:childTnLst>
-                          </p:cTn>
-                        </p:par>
-                      </p:childTnLst>
-                    </p:cTn>
-                  </p:par>
-                </p:childTnLst>
-              </p:cTn>
-              <p:prevCondLst>
-                <p:cond evt="onPrev" delay="0">
-                  <p:tgtEl>
-                    <p:sldTgt/>
-                  </p:tgtEl>
-                </p:cond>
-              </p:prevCondLst>
-              <p:nextCondLst>
-                <p:cond evt="onNext" delay="0">
-                  <p:tgtEl>
-                    <p:sldTgt/>
-                  </p:tgtEl>
-                </p:cond>
-              </p:nextCondLst>
-            </p:seq>
-          </p:childTnLst>
-        </p:cTn>
-      </p:par>
-    </p:tnLst>
-    <p:bldLst>
-      <p:bldP spid="6" grpId="0"/>
-      <p:bldP spid="7" grpId="0" animBg="1"/>
-    </p:bldLst>
-  </p:timing>
-</p:sld>
-</file>
-
-<file path=ppt/slides/slide26.xml><?xml version="1.0" encoding="utf-8"?>
-<p:sld xmlns:a="http://schemas.openxmlformats.org/drawingml/2006/main" xmlns:r="http://schemas.openxmlformats.org/officeDocument/2006/relationships" xmlns:p="http://schemas.openxmlformats.org/presentationml/2006/main">
-  <p:cSld>
-    <p:spTree>
-      <p:nvGrpSpPr>
-        <p:cNvPr id="1" name=""/>
-        <p:cNvGrpSpPr/>
-        <p:nvPr/>
-      </p:nvGrpSpPr>
-      <p:grpSpPr>
-        <a:xfrm>
-          <a:off x="0" y="0"/>
-          <a:ext cx="0" cy="0"/>
-          <a:chOff x="0" y="0"/>
-          <a:chExt cx="0" cy="0"/>
-        </a:xfrm>
-      </p:grpSpPr>
-      <p:sp>
-        <p:nvSpPr>
-          <p:cNvPr id="2" name="Title 1">
-            <a:extLst>
-              <a:ext uri="{FF2B5EF4-FFF2-40B4-BE49-F238E27FC236}">
-                <a16:creationId xmlns:a16="http://schemas.microsoft.com/office/drawing/2014/main" id="{D617AB41-6AD1-9EF2-7F95-46A904399681}"/>
-              </a:ext>
-            </a:extLst>
-          </p:cNvPr>
-          <p:cNvSpPr>
-            <a:spLocks noGrp="1"/>
-          </p:cNvSpPr>
-          <p:nvPr>
-            <p:ph type="title"/>
-          </p:nvPr>
-        </p:nvSpPr>
-        <p:spPr/>
-        <p:txBody>
-          <a:bodyPr>
-            <a:noAutofit/>
-          </a:bodyPr>
-          <a:lstStyle/>
-          <a:p>
-            <a:r>
-              <a:rPr lang="en-US">
-                <a:solidFill>
-                  <a:srgbClr val="1F3864"/>
-                </a:solidFill>
-              </a:rPr>
-              <a:t>The language of probability</a:t>
-            </a:r>
-          </a:p>
-        </p:txBody>
-      </p:sp>
-      <p:sp>
-        <p:nvSpPr>
-          <p:cNvPr id="4" name="Slide Number Placeholder 3">
-            <a:extLst>
-              <a:ext uri="{FF2B5EF4-FFF2-40B4-BE49-F238E27FC236}">
-                <a16:creationId xmlns:a16="http://schemas.microsoft.com/office/drawing/2014/main" id="{97D44AE5-98B5-B840-6B8A-D345C7C2E2F0}"/>
-              </a:ext>
-            </a:extLst>
-          </p:cNvPr>
-          <p:cNvSpPr>
-            <a:spLocks noGrp="1"/>
-          </p:cNvSpPr>
-          <p:nvPr>
-            <p:ph type="sldNum" sz="quarter" idx="12"/>
-          </p:nvPr>
-        </p:nvSpPr>
-        <p:spPr/>
-        <p:txBody>
-          <a:bodyPr/>
-          <a:lstStyle/>
-          <a:p>
-            <a:fld id="{A80A81DD-F10A-4B1C-963A-0ABBB4865886}" type="slidenum">
-              <a:rPr lang="en-US" sz="1600" smtClean="0"/>
-              <a:t>26</a:t>
-            </a:fld>
-            <a:endParaRPr lang="en-US" sz="1600"/>
-          </a:p>
-        </p:txBody>
-      </p:sp>
-      <p:sp>
-        <p:nvSpPr>
-          <p:cNvPr id="5" name="TextBox 4">
-            <a:extLst>
-              <a:ext uri="{FF2B5EF4-FFF2-40B4-BE49-F238E27FC236}">
-                <a16:creationId xmlns:a16="http://schemas.microsoft.com/office/drawing/2014/main" id="{A34AAE17-27CE-D7A3-C663-11BB48ACBF5B}"/>
-              </a:ext>
-            </a:extLst>
-          </p:cNvPr>
-          <p:cNvSpPr txBox="1"/>
-          <p:nvPr/>
-        </p:nvSpPr>
-        <p:spPr>
-          <a:xfrm>
-            <a:off x="762000" y="1879600"/>
-            <a:ext cx="10668000" cy="345440"/>
-          </a:xfrm>
-          <a:prstGeom prst="rect">
-            <a:avLst/>
-          </a:prstGeom>
-          <a:noFill/>
-        </p:spPr>
-        <p:txBody>
-          <a:bodyPr vert="horz" wrap="square" rtlCol="0">
-            <a:spAutoFit/>
-          </a:bodyPr>
-          <a:lstStyle/>
-          <a:p>
-            <a:pPr marL="304800" indent="-304800"/>
-            <a:r>
-              <a:rPr lang="en-US" sz="1600">
-                <a:solidFill>
-                  <a:srgbClr val="000000"/>
-                </a:solidFill>
-              </a:rPr>
-              <a:t>chance experiment</a:t>
-            </a:r>
-          </a:p>
-        </p:txBody>
-      </p:sp>
-      <p:sp>
-        <p:nvSpPr>
-          <p:cNvPr id="6" name="TextBox 5">
-            <a:extLst>
-              <a:ext uri="{FF2B5EF4-FFF2-40B4-BE49-F238E27FC236}">
-                <a16:creationId xmlns:a16="http://schemas.microsoft.com/office/drawing/2014/main" id="{E410A0F8-5E1E-9A1D-B64C-50827EE6C9B2}"/>
-              </a:ext>
-            </a:extLst>
-          </p:cNvPr>
-          <p:cNvSpPr txBox="1"/>
-          <p:nvPr/>
-        </p:nvSpPr>
-        <p:spPr>
-          <a:xfrm>
-            <a:off x="1117600" y="2225040"/>
-            <a:ext cx="10312400" cy="338554"/>
-          </a:xfrm>
-          <a:prstGeom prst="rect">
-            <a:avLst/>
-          </a:prstGeom>
-          <a:noFill/>
-        </p:spPr>
-        <p:txBody>
-          <a:bodyPr vert="horz" wrap="square" rtlCol="0">
-            <a:spAutoFit/>
-          </a:bodyPr>
-          <a:lstStyle/>
-          <a:p>
-            <a:r>
-              <a:rPr lang="en-US" sz="1600" b="1">
-                <a:solidFill>
-                  <a:srgbClr val="C00000"/>
-                </a:solidFill>
-              </a:rPr>
-              <a:t>a process whose result cannot be predicted in advance, such as rolling a die</a:t>
-            </a:r>
-          </a:p>
-        </p:txBody>
-      </p:sp>
-      <p:sp>
-        <p:nvSpPr>
-          <p:cNvPr id="7" name="TextBox 6">
-            <a:extLst>
-              <a:ext uri="{FF2B5EF4-FFF2-40B4-BE49-F238E27FC236}">
-                <a16:creationId xmlns:a16="http://schemas.microsoft.com/office/drawing/2014/main" id="{47D3CD95-D52E-5227-B663-7C0A72677B6E}"/>
-              </a:ext>
-            </a:extLst>
-          </p:cNvPr>
-          <p:cNvSpPr txBox="1"/>
-          <p:nvPr/>
-        </p:nvSpPr>
-        <p:spPr>
-          <a:xfrm>
-            <a:off x="762000" y="2766794"/>
-            <a:ext cx="10668000" cy="345440"/>
-          </a:xfrm>
-          <a:prstGeom prst="rect">
-            <a:avLst/>
-          </a:prstGeom>
-          <a:noFill/>
-        </p:spPr>
-        <p:txBody>
-          <a:bodyPr vert="horz" wrap="square" rtlCol="0">
-            <a:spAutoFit/>
-          </a:bodyPr>
-          <a:lstStyle/>
-          <a:p>
-            <a:pPr marL="304800" indent="-304800"/>
-            <a:r>
-              <a:rPr lang="en-US" sz="1600">
-                <a:solidFill>
-                  <a:srgbClr val="000000"/>
-                </a:solidFill>
-              </a:rPr>
-              <a:t>sample space  S</a:t>
-            </a:r>
-          </a:p>
-        </p:txBody>
-      </p:sp>
-      <p:sp>
-        <p:nvSpPr>
-          <p:cNvPr id="8" name="TextBox 7">
-            <a:extLst>
-              <a:ext uri="{FF2B5EF4-FFF2-40B4-BE49-F238E27FC236}">
-                <a16:creationId xmlns:a16="http://schemas.microsoft.com/office/drawing/2014/main" id="{1CE3E601-601D-C6B1-8265-C079CB8C9269}"/>
-              </a:ext>
-            </a:extLst>
-          </p:cNvPr>
-          <p:cNvSpPr txBox="1"/>
-          <p:nvPr/>
-        </p:nvSpPr>
-        <p:spPr>
-          <a:xfrm>
-            <a:off x="1117600" y="3112234"/>
-            <a:ext cx="10312400" cy="338554"/>
-          </a:xfrm>
-          <a:prstGeom prst="rect">
-            <a:avLst/>
-          </a:prstGeom>
-          <a:noFill/>
-        </p:spPr>
-        <p:txBody>
-          <a:bodyPr vert="horz" wrap="square" rtlCol="0">
-            <a:spAutoFit/>
-          </a:bodyPr>
-          <a:lstStyle/>
-          <a:p>
-            <a:r>
-              <a:rPr lang="en-US" sz="1600" b="1">
-                <a:solidFill>
-                  <a:srgbClr val="C00000"/>
-                </a:solidFill>
-              </a:rPr>
-              <a:t>the set of all possible outcomes: for one roll of a die, S = {1, 2, 3, 4, 5, 6}</a:t>
-            </a:r>
-          </a:p>
-        </p:txBody>
-      </p:sp>
-      <p:sp>
-        <p:nvSpPr>
-          <p:cNvPr id="9" name="TextBox 8">
-            <a:extLst>
-              <a:ext uri="{FF2B5EF4-FFF2-40B4-BE49-F238E27FC236}">
-                <a16:creationId xmlns:a16="http://schemas.microsoft.com/office/drawing/2014/main" id="{FB002BF4-8037-2F73-E27A-7A453477E389}"/>
-              </a:ext>
-            </a:extLst>
-          </p:cNvPr>
-          <p:cNvSpPr txBox="1"/>
-          <p:nvPr/>
-        </p:nvSpPr>
-        <p:spPr>
-          <a:xfrm>
-            <a:off x="762000" y="3653988"/>
-            <a:ext cx="10668000" cy="345440"/>
-          </a:xfrm>
-          <a:prstGeom prst="rect">
-            <a:avLst/>
-          </a:prstGeom>
-          <a:noFill/>
-        </p:spPr>
-        <p:txBody>
-          <a:bodyPr vert="horz" wrap="square" rtlCol="0">
-            <a:spAutoFit/>
-          </a:bodyPr>
-          <a:lstStyle/>
-          <a:p>
-            <a:pPr marL="304800" indent="-304800"/>
-            <a:r>
-              <a:rPr lang="en-US" sz="1600">
-                <a:solidFill>
-                  <a:srgbClr val="000000"/>
-                </a:solidFill>
-              </a:rPr>
-              <a:t>event</a:t>
-            </a:r>
-          </a:p>
-        </p:txBody>
-      </p:sp>
-      <p:sp>
-        <p:nvSpPr>
-          <p:cNvPr id="10" name="TextBox 9">
-            <a:extLst>
-              <a:ext uri="{FF2B5EF4-FFF2-40B4-BE49-F238E27FC236}">
-                <a16:creationId xmlns:a16="http://schemas.microsoft.com/office/drawing/2014/main" id="{10F3B3E3-D27C-E008-C93E-ED70BD2A4754}"/>
-              </a:ext>
-            </a:extLst>
-          </p:cNvPr>
-          <p:cNvSpPr txBox="1"/>
-          <p:nvPr/>
-        </p:nvSpPr>
-        <p:spPr>
-          <a:xfrm>
-            <a:off x="1117600" y="3999428"/>
-            <a:ext cx="10312400" cy="338554"/>
-          </a:xfrm>
-          <a:prstGeom prst="rect">
-            <a:avLst/>
-          </a:prstGeom>
-          <a:noFill/>
-        </p:spPr>
-        <p:txBody>
-          <a:bodyPr vert="horz" wrap="square" rtlCol="0">
-            <a:spAutoFit/>
-          </a:bodyPr>
-          <a:lstStyle/>
-          <a:p>
-            <a:r>
-              <a:rPr lang="en-US" sz="1600" b="1">
-                <a:solidFill>
-                  <a:srgbClr val="C00000"/>
-                </a:solidFill>
-              </a:rPr>
-              <a:t>any collection of outcomes, written with a capital letter: A = {roll an even number} = {2, 4, 6}</a:t>
-            </a:r>
-          </a:p>
-        </p:txBody>
-      </p:sp>
-      <p:sp>
-        <p:nvSpPr>
-          <p:cNvPr id="3" name="Title rule">
-            <a:extLst>
-              <a:ext uri="{FF2B5EF4-FFF2-40B4-BE49-F238E27FC236}">
-                <a16:creationId xmlns:a16="http://schemas.microsoft.com/office/drawing/2014/main" id="{B469CAAB-2B69-6863-7C28-0C5959E5734B}"/>
-              </a:ext>
-            </a:extLst>
-          </p:cNvPr>
-          <p:cNvSpPr/>
-          <p:nvPr/>
-        </p:nvSpPr>
-        <p:spPr>
-          <a:xfrm>
-            <a:off x="838200" y="1600200"/>
-            <a:ext cx="10515600" cy="38100"/>
-          </a:xfrm>
-          <a:prstGeom prst="rect">
-            <a:avLst/>
-          </a:prstGeom>
-          <a:solidFill>
-            <a:srgbClr val="4472C4"/>
-          </a:solidFill>
-          <a:ln w="12700" cap="flat" cmpd="sng" algn="ctr">
-            <a:noFill/>
-            <a:prstDash val="solid"/>
-            <a:miter lim="800000"/>
-          </a:ln>
-          <a:effectLst/>
-          <a:extLst>
-            <a:ext uri="{91240B29-F687-4F45-9708-019B960494DF}">
-              <a14:hiddenLine xmlns:a14="http://schemas.microsoft.com/office/drawing/2010/main" w="12700" cap="flat" cmpd="sng" algn="ctr">
-                <a:solidFill>
-                  <a:schemeClr val="accent1">
-                    <a:shade val="15000"/>
-                  </a:schemeClr>
-                </a:solidFill>
-                <a:prstDash val="solid"/>
-                <a:miter lim="800000"/>
-              </a14:hiddenLine>
-            </a:ext>
-          </a:extLst>
-        </p:spPr>
-        <p:style>
-          <a:lnRef idx="2">
-            <a:schemeClr val="accent1">
-              <a:shade val="15000"/>
-            </a:schemeClr>
-          </a:lnRef>
-          <a:fillRef idx="1">
-            <a:schemeClr val="accent1"/>
-          </a:fillRef>
-          <a:effectRef idx="0">
-            <a:schemeClr val="accent1"/>
-          </a:effectRef>
-          <a:fontRef idx="minor">
-            <a:schemeClr val="lt1"/>
-          </a:fontRef>
-        </p:style>
-        <p:txBody>
-          <a:bodyPr rtlCol="0" anchor="ctr"/>
-          <a:lstStyle/>
-          <a:p>
-            <a:pPr algn="ctr"/>
-            <a:endParaRPr lang="en-US"/>
-          </a:p>
-        </p:txBody>
-      </p:sp>
-    </p:spTree>
-    <p:extLst>
-      <p:ext uri="{BB962C8B-B14F-4D97-AF65-F5344CB8AC3E}">
-        <p14:creationId xmlns:p14="http://schemas.microsoft.com/office/powerpoint/2010/main" val="1868401000"/>
-      </p:ext>
-    </p:extLst>
-  </p:cSld>
-  <p:clrMapOvr>
-    <a:masterClrMapping/>
-  </p:clrMapOvr>
-  <p:timing>
-    <p:tnLst>
-      <p:par>
-        <p:cTn id="1" dur="indefinite" restart="never" nodeType="tmRoot">
-          <p:childTnLst>
-            <p:seq concurrent="1" nextAc="seek">
-              <p:cTn id="2" dur="indefinite" nodeType="mainSeq">
-                <p:childTnLst>
-                  <p:par>
-                    <p:cTn id="3" fill="hold">
-                      <p:stCondLst>
-                        <p:cond delay="indefinite"/>
-                      </p:stCondLst>
-                      <p:childTnLst>
-                        <p:par>
-                          <p:cTn id="4" fill="hold">
-                            <p:stCondLst>
-                              <p:cond delay="0"/>
-                            </p:stCondLst>
-                            <p:childTnLst>
-                              <p:par>
-                                <p:cTn id="5" presetID="34" presetClass="entr" presetSubtype="0" fill="hold" grpId="0" nodeType="clickEffect">
-                                  <p:stCondLst>
-                                    <p:cond delay="0"/>
-                                  </p:stCondLst>
-                                  <p:childTnLst>
-                                    <p:set>
-                                      <p:cBhvr>
-                                        <p:cTn id="6" dur="1" fill="hold">
-                                          <p:stCondLst>
-                                            <p:cond delay="0"/>
-                                          </p:stCondLst>
-                                        </p:cTn>
-                                        <p:tgtEl>
-                                          <p:spTgt spid="6"/>
-                                        </p:tgtEl>
-                                        <p:attrNameLst>
-                                          <p:attrName>style.visibility</p:attrName>
-                                        </p:attrNameLst>
-                                      </p:cBhvr>
-                                      <p:to>
-                                        <p:strVal val="visible"/>
-                                      </p:to>
-                                    </p:set>
-                                    <p:anim from="(-#ppt_w/2)" to="(#ppt_x)" calcmode="lin" valueType="num">
-                                      <p:cBhvr>
-                                        <p:cTn id="7" dur="600" fill="hold">
-                                          <p:stCondLst>
-                                            <p:cond delay="0"/>
-                                          </p:stCondLst>
-                                        </p:cTn>
-                                        <p:tgtEl>
-                                          <p:spTgt spid="6"/>
-                                        </p:tgtEl>
-                                        <p:attrNameLst>
-                                          <p:attrName>ppt_x</p:attrName>
-                                        </p:attrNameLst>
-                                      </p:cBhvr>
-                                    </p:anim>
-                                    <p:anim from="0" to="-1.0" calcmode="lin" valueType="num">
-                                      <p:cBhvr>
-                                        <p:cTn id="8" dur="200" decel="50000" autoRev="1" fill="hold">
-                                          <p:stCondLst>
-                                            <p:cond delay="600"/>
-                                          </p:stCondLst>
-                                        </p:cTn>
-                                        <p:tgtEl>
-                                          <p:spTgt spid="6"/>
-                                        </p:tgtEl>
-                                        <p:attrNameLst>
-                                          <p:attrName>xshear</p:attrName>
-                                        </p:attrNameLst>
-                                      </p:cBhvr>
-                                    </p:anim>
-                                    <p:animScale>
-                                      <p:cBhvr>
-                                        <p:cTn id="9" dur="200" decel="100000" autoRev="1" fill="hold">
-                                          <p:stCondLst>
-                                            <p:cond delay="600"/>
-                                          </p:stCondLst>
-                                        </p:cTn>
-                                        <p:tgtEl>
-                                          <p:spTgt spid="6"/>
-                                        </p:tgtEl>
-                                      </p:cBhvr>
-                                      <p:from x="100000" y="100000"/>
-                                      <p:to x="80000" y="100000"/>
-                                    </p:animScale>
-                                    <p:anim by="(#ppt_h/3+#ppt_w*0.1)" calcmode="lin" valueType="num">
-                                      <p:cBhvr additive="sum">
-                                        <p:cTn id="10" dur="200" decel="100000" autoRev="1" fill="hold">
-                                          <p:stCondLst>
-                                            <p:cond delay="600"/>
-                                          </p:stCondLst>
-                                        </p:cTn>
-                                        <p:tgtEl>
-                                          <p:spTgt spid="6"/>
-                                        </p:tgtEl>
-                                        <p:attrNameLst>
-                                          <p:attrName>ppt_x</p:attrName>
-                                        </p:attrNameLst>
-                                      </p:cBhvr>
-                                    </p:anim>
-                                  </p:childTnLst>
-                                </p:cTn>
-                              </p:par>
-                            </p:childTnLst>
-                          </p:cTn>
-                        </p:par>
-                      </p:childTnLst>
-                    </p:cTn>
-                  </p:par>
-                  <p:par>
-                    <p:cTn id="11" fill="hold">
-                      <p:stCondLst>
-                        <p:cond delay="indefinite"/>
-                      </p:stCondLst>
-                      <p:childTnLst>
-                        <p:par>
-                          <p:cTn id="12" fill="hold">
-                            <p:stCondLst>
-                              <p:cond delay="0"/>
-                            </p:stCondLst>
-                            <p:childTnLst>
-                              <p:par>
-                                <p:cTn id="13" presetID="34" presetClass="entr" presetSubtype="0" fill="hold" grpId="0" nodeType="clickEffect">
-                                  <p:stCondLst>
-                                    <p:cond delay="0"/>
-                                  </p:stCondLst>
-                                  <p:childTnLst>
-                                    <p:set>
-                                      <p:cBhvr>
-                                        <p:cTn id="14" dur="1" fill="hold">
-                                          <p:stCondLst>
-                                            <p:cond delay="0"/>
-                                          </p:stCondLst>
-                                        </p:cTn>
-                                        <p:tgtEl>
-                                          <p:spTgt spid="8"/>
-                                        </p:tgtEl>
-                                        <p:attrNameLst>
-                                          <p:attrName>style.visibility</p:attrName>
-                                        </p:attrNameLst>
-                                      </p:cBhvr>
-                                      <p:to>
-                                        <p:strVal val="visible"/>
-                                      </p:to>
-                                    </p:set>
-                                    <p:anim from="(-#ppt_w/2)" to="(#ppt_x)" calcmode="lin" valueType="num">
-                                      <p:cBhvr>
-                                        <p:cTn id="15" dur="600" fill="hold">
-                                          <p:stCondLst>
-                                            <p:cond delay="0"/>
-                                          </p:stCondLst>
-                                        </p:cTn>
-                                        <p:tgtEl>
-                                          <p:spTgt spid="8"/>
-                                        </p:tgtEl>
-                                        <p:attrNameLst>
-                                          <p:attrName>ppt_x</p:attrName>
-                                        </p:attrNameLst>
-                                      </p:cBhvr>
-                                    </p:anim>
-                                    <p:anim from="0" to="-1.0" calcmode="lin" valueType="num">
-                                      <p:cBhvr>
-                                        <p:cTn id="16" dur="200" decel="50000" autoRev="1" fill="hold">
-                                          <p:stCondLst>
-                                            <p:cond delay="600"/>
-                                          </p:stCondLst>
-                                        </p:cTn>
-                                        <p:tgtEl>
-                                          <p:spTgt spid="8"/>
-                                        </p:tgtEl>
-                                        <p:attrNameLst>
-                                          <p:attrName>xshear</p:attrName>
-                                        </p:attrNameLst>
-                                      </p:cBhvr>
-                                    </p:anim>
-                                    <p:animScale>
-                                      <p:cBhvr>
-                                        <p:cTn id="17" dur="200" decel="100000" autoRev="1" fill="hold">
-                                          <p:stCondLst>
-                                            <p:cond delay="600"/>
-                                          </p:stCondLst>
-                                        </p:cTn>
-                                        <p:tgtEl>
-                                          <p:spTgt spid="8"/>
-                                        </p:tgtEl>
-                                      </p:cBhvr>
-                                      <p:from x="100000" y="100000"/>
-                                      <p:to x="80000" y="100000"/>
-                                    </p:animScale>
-                                    <p:anim by="(#ppt_h/3+#ppt_w*0.1)" calcmode="lin" valueType="num">
-                                      <p:cBhvr additive="sum">
-                                        <p:cTn id="18" dur="200" decel="100000" autoRev="1" fill="hold">
-                                          <p:stCondLst>
-                                            <p:cond delay="600"/>
-                                          </p:stCondLst>
-                                        </p:cTn>
-                                        <p:tgtEl>
-                                          <p:spTgt spid="8"/>
-                                        </p:tgtEl>
-                                        <p:attrNameLst>
-                                          <p:attrName>ppt_x</p:attrName>
-                                        </p:attrNameLst>
-                                      </p:cBhvr>
-                                    </p:anim>
-                                  </p:childTnLst>
-                                </p:cTn>
-                              </p:par>
-                            </p:childTnLst>
-                          </p:cTn>
-                        </p:par>
-                      </p:childTnLst>
-                    </p:cTn>
-                  </p:par>
-                  <p:par>
-                    <p:cTn id="19" fill="hold">
-                      <p:stCondLst>
-                        <p:cond delay="indefinite"/>
-                      </p:stCondLst>
-                      <p:childTnLst>
-                        <p:par>
-                          <p:cTn id="20" fill="hold">
-                            <p:stCondLst>
-                              <p:cond delay="0"/>
-                            </p:stCondLst>
-                            <p:childTnLst>
-                              <p:par>
-                                <p:cTn id="21" presetID="34" presetClass="entr" presetSubtype="0" fill="hold" grpId="0" nodeType="clickEffect">
-                                  <p:stCondLst>
-                                    <p:cond delay="0"/>
-                                  </p:stCondLst>
-                                  <p:childTnLst>
-                                    <p:set>
-                                      <p:cBhvr>
-                                        <p:cTn id="22" dur="1" fill="hold">
-                                          <p:stCondLst>
-                                            <p:cond delay="0"/>
-                                          </p:stCondLst>
-                                        </p:cTn>
-                                        <p:tgtEl>
-                                          <p:spTgt spid="10"/>
-                                        </p:tgtEl>
-                                        <p:attrNameLst>
-                                          <p:attrName>style.visibility</p:attrName>
-                                        </p:attrNameLst>
-                                      </p:cBhvr>
-                                      <p:to>
-                                        <p:strVal val="visible"/>
-                                      </p:to>
-                                    </p:set>
-                                    <p:anim from="(-#ppt_w/2)" to="(#ppt_x)" calcmode="lin" valueType="num">
-                                      <p:cBhvr>
-                                        <p:cTn id="23" dur="600" fill="hold">
-                                          <p:stCondLst>
-                                            <p:cond delay="0"/>
-                                          </p:stCondLst>
-                                        </p:cTn>
-                                        <p:tgtEl>
-                                          <p:spTgt spid="10"/>
-                                        </p:tgtEl>
-                                        <p:attrNameLst>
-                                          <p:attrName>ppt_x</p:attrName>
-                                        </p:attrNameLst>
-                                      </p:cBhvr>
-                                    </p:anim>
-                                    <p:anim from="0" to="-1.0" calcmode="lin" valueType="num">
-                                      <p:cBhvr>
-                                        <p:cTn id="24" dur="200" decel="50000" autoRev="1" fill="hold">
-                                          <p:stCondLst>
-                                            <p:cond delay="600"/>
-                                          </p:stCondLst>
-                                        </p:cTn>
-                                        <p:tgtEl>
-                                          <p:spTgt spid="10"/>
-                                        </p:tgtEl>
-                                        <p:attrNameLst>
-                                          <p:attrName>xshear</p:attrName>
-                                        </p:attrNameLst>
-                                      </p:cBhvr>
-                                    </p:anim>
-                                    <p:animScale>
-                                      <p:cBhvr>
-                                        <p:cTn id="25" dur="200" decel="100000" autoRev="1" fill="hold">
-                                          <p:stCondLst>
-                                            <p:cond delay="600"/>
-                                          </p:stCondLst>
-                                        </p:cTn>
-                                        <p:tgtEl>
-                                          <p:spTgt spid="10"/>
-                                        </p:tgtEl>
-                                      </p:cBhvr>
-                                      <p:from x="100000" y="100000"/>
-                                      <p:to x="80000" y="100000"/>
-                                    </p:animScale>
-                                    <p:anim by="(#ppt_h/3+#ppt_w*0.1)" calcmode="lin" valueType="num">
-                                      <p:cBhvr additive="sum">
-                                        <p:cTn id="26" dur="200" decel="100000" autoRev="1" fill="hold">
-                                          <p:stCondLst>
-                                            <p:cond delay="600"/>
-                                          </p:stCondLst>
-                                        </p:cTn>
-                                        <p:tgtEl>
-                                          <p:spTgt spid="10"/>
-                                        </p:tgtEl>
-                                        <p:attrNameLst>
-                                          <p:attrName>ppt_x</p:attrName>
-                                        </p:attrNameLst>
-                                      </p:cBhvr>
-                                    </p:anim>
-                                  </p:childTnLst>
-                                </p:cTn>
-                              </p:par>
-                            </p:childTnLst>
-                          </p:cTn>
-                        </p:par>
-                      </p:childTnLst>
-                    </p:cTn>
-                  </p:par>
-                </p:childTnLst>
-              </p:cTn>
-              <p:prevCondLst>
-                <p:cond evt="onPrev" delay="0">
-                  <p:tgtEl>
-                    <p:sldTgt/>
-                  </p:tgtEl>
-                </p:cond>
-              </p:prevCondLst>
-              <p:nextCondLst>
-                <p:cond evt="onNext" delay="0">
-                  <p:tgtEl>
-                    <p:sldTgt/>
-                  </p:tgtEl>
-                </p:cond>
-              </p:nextCondLst>
-            </p:seq>
-          </p:childTnLst>
-        </p:cTn>
-      </p:par>
-    </p:tnLst>
-    <p:bldLst>
-      <p:bldP spid="6" grpId="0"/>
-      <p:bldP spid="8" grpId="0"/>
-      <p:bldP spid="10" grpId="0"/>
-    </p:bldLst>
-  </p:timing>
-</p:sld>
-</file>
-
-<file path=ppt/slides/slide27.xml><?xml version="1.0" encoding="utf-8"?>
-<p:sld xmlns:a="http://schemas.openxmlformats.org/drawingml/2006/main" xmlns:r="http://schemas.openxmlformats.org/officeDocument/2006/relationships" xmlns:p="http://schemas.openxmlformats.org/presentationml/2006/main">
-  <p:cSld>
-    <p:spTree>
-      <p:nvGrpSpPr>
-        <p:cNvPr id="1" name=""/>
-        <p:cNvGrpSpPr/>
-        <p:nvPr/>
-      </p:nvGrpSpPr>
-      <p:grpSpPr>
-        <a:xfrm>
-          <a:off x="0" y="0"/>
-          <a:ext cx="0" cy="0"/>
-          <a:chOff x="0" y="0"/>
-          <a:chExt cx="0" cy="0"/>
-        </a:xfrm>
-      </p:grpSpPr>
-      <p:sp>
-        <p:nvSpPr>
-          <p:cNvPr id="2" name="Title 1">
-            <a:extLst>
-              <a:ext uri="{FF2B5EF4-FFF2-40B4-BE49-F238E27FC236}">
-                <a16:creationId xmlns:a16="http://schemas.microsoft.com/office/drawing/2014/main" id="{C08D30B1-1864-30EF-7EAB-9BEE656C0012}"/>
-              </a:ext>
-            </a:extLst>
-          </p:cNvPr>
-          <p:cNvSpPr>
-            <a:spLocks noGrp="1"/>
-          </p:cNvSpPr>
-          <p:nvPr>
-            <p:ph type="title"/>
-          </p:nvPr>
-        </p:nvSpPr>
-        <p:spPr/>
-        <p:txBody>
-          <a:bodyPr>
-            <a:noAutofit/>
-          </a:bodyPr>
-          <a:lstStyle/>
-          <a:p>
-            <a:r>
-              <a:rPr lang="en-US">
-                <a:solidFill>
-                  <a:srgbClr val="1F3864"/>
-                </a:solidFill>
-              </a:rPr>
-              <a:t>Equally likely outcomes</a:t>
-            </a:r>
-          </a:p>
-        </p:txBody>
-      </p:sp>
-      <p:sp>
-        <p:nvSpPr>
-          <p:cNvPr id="4" name="Slide Number Placeholder 3">
-            <a:extLst>
-              <a:ext uri="{FF2B5EF4-FFF2-40B4-BE49-F238E27FC236}">
-                <a16:creationId xmlns:a16="http://schemas.microsoft.com/office/drawing/2014/main" id="{3F875068-D051-44AE-498E-1BEBEDE3A7C8}"/>
-              </a:ext>
-            </a:extLst>
-          </p:cNvPr>
-          <p:cNvSpPr>
-            <a:spLocks noGrp="1"/>
-          </p:cNvSpPr>
-          <p:nvPr>
-            <p:ph type="sldNum" sz="quarter" idx="12"/>
-          </p:nvPr>
-        </p:nvSpPr>
-        <p:spPr/>
-        <p:txBody>
-          <a:bodyPr/>
-          <a:lstStyle/>
-          <a:p>
-            <a:fld id="{A80A81DD-F10A-4B1C-963A-0ABBB4865886}" type="slidenum">
-              <a:rPr lang="en-US" sz="1600" smtClean="0"/>
-              <a:t>27</a:t>
-            </a:fld>
-            <a:endParaRPr lang="en-US" sz="1600"/>
-          </a:p>
-        </p:txBody>
-      </p:sp>
-      <p:sp>
-        <p:nvSpPr>
-          <p:cNvPr id="3" name="Title rule">
-            <a:extLst>
-              <a:ext uri="{FF2B5EF4-FFF2-40B4-BE49-F238E27FC236}">
-                <a16:creationId xmlns:a16="http://schemas.microsoft.com/office/drawing/2014/main" id="{30656AA8-9645-F028-C769-A313710853CC}"/>
-              </a:ext>
-            </a:extLst>
-          </p:cNvPr>
-          <p:cNvSpPr/>
-          <p:nvPr/>
-        </p:nvSpPr>
-        <p:spPr>
-          <a:xfrm>
-            <a:off x="838200" y="1600200"/>
-            <a:ext cx="10515600" cy="38100"/>
-          </a:xfrm>
-          <a:prstGeom prst="rect">
-            <a:avLst/>
-          </a:prstGeom>
-          <a:solidFill>
-            <a:srgbClr val="4472C4"/>
-          </a:solidFill>
-          <a:ln w="12700" cap="flat" cmpd="sng" algn="ctr">
-            <a:noFill/>
-            <a:prstDash val="solid"/>
-            <a:miter lim="800000"/>
-          </a:ln>
-          <a:effectLst/>
-          <a:extLst>
-            <a:ext uri="{91240B29-F687-4F45-9708-019B960494DF}">
-              <a14:hiddenLine xmlns:a14="http://schemas.microsoft.com/office/drawing/2010/main" w="12700" cap="flat" cmpd="sng" algn="ctr">
-                <a:solidFill>
-                  <a:schemeClr val="accent1">
-                    <a:shade val="15000"/>
-                  </a:schemeClr>
-                </a:solidFill>
-                <a:prstDash val="solid"/>
-                <a:miter lim="800000"/>
-              </a14:hiddenLine>
-            </a:ext>
-          </a:extLst>
-        </p:spPr>
-        <p:style>
-          <a:lnRef idx="2">
-            <a:schemeClr val="accent1">
-              <a:shade val="15000"/>
-            </a:schemeClr>
-          </a:lnRef>
-          <a:fillRef idx="1">
-            <a:schemeClr val="accent1"/>
-          </a:fillRef>
-          <a:effectRef idx="0">
-            <a:schemeClr val="accent1"/>
-          </a:effectRef>
-          <a:fontRef idx="minor">
-            <a:schemeClr val="lt1"/>
-          </a:fontRef>
-        </p:style>
-        <p:txBody>
-          <a:bodyPr rtlCol="0" anchor="ctr"/>
-          <a:lstStyle/>
-          <a:p>
-            <a:pPr algn="ctr"/>
-            <a:endParaRPr lang="en-US"/>
-          </a:p>
-        </p:txBody>
-      </p:sp>
-      <p:sp>
-        <p:nvSpPr>
-          <p:cNvPr id="8" name="Context">
-            <a:extLst>
-              <a:ext uri="{FF2B5EF4-FFF2-40B4-BE49-F238E27FC236}">
-                <a16:creationId xmlns:a16="http://schemas.microsoft.com/office/drawing/2014/main" id="{71E3EA8C-31B4-DAD4-BC4A-65D72E59AD46}"/>
-              </a:ext>
-            </a:extLst>
-          </p:cNvPr>
-          <p:cNvSpPr txBox="1"/>
-          <p:nvPr/>
-        </p:nvSpPr>
-        <p:spPr>
-          <a:xfrm>
-            <a:off x="762000" y="1879600"/>
-            <a:ext cx="10668000" cy="381000"/>
-          </a:xfrm>
-          <a:prstGeom prst="rect">
-            <a:avLst/>
-          </a:prstGeom>
-          <a:noFill/>
-        </p:spPr>
-        <p:txBody>
-          <a:bodyPr vert="horz" wrap="square" rtlCol="0">
-            <a:spAutoFit/>
-          </a:bodyPr>
-          <a:lstStyle/>
-          <a:p>
-            <a:pPr>
-              <a:spcAft>
-                <a:spcPts val="200"/>
-              </a:spcAft>
-            </a:pPr>
-            <a:r>
-              <a:rPr lang="en-US">
-                <a:solidFill>
-                  <a:srgbClr val="000000"/>
-                </a:solidFill>
-                <a:latin typeface="Calibri" panose="020F0502020204030204" pitchFamily="34" charset="0"/>
-              </a:rPr>
-              <a:t>Roll a fair six-sided die: all six outcomes are equally likely.</a:t>
-            </a:r>
-          </a:p>
-        </p:txBody>
-      </p:sp>
-      <p:sp>
-        <p:nvSpPr>
-          <p:cNvPr id="9" name="Numbers">
-            <a:extLst>
-              <a:ext uri="{FF2B5EF4-FFF2-40B4-BE49-F238E27FC236}">
-                <a16:creationId xmlns:a16="http://schemas.microsoft.com/office/drawing/2014/main" id="{C419F151-05B2-3E4B-BAE8-BB1F06D9D1FD}"/>
-              </a:ext>
-            </a:extLst>
-          </p:cNvPr>
-          <p:cNvSpPr txBox="1"/>
-          <p:nvPr/>
-        </p:nvSpPr>
-        <p:spPr>
-          <a:xfrm>
-            <a:off x="762000" y="2286000"/>
-            <a:ext cx="10668000" cy="400110"/>
-          </a:xfrm>
-          <a:prstGeom prst="rect">
-            <a:avLst/>
-          </a:prstGeom>
-          <a:noFill/>
-        </p:spPr>
-        <p:txBody>
-          <a:bodyPr vert="horz" wrap="square" rtlCol="0">
-            <a:spAutoFit/>
-          </a:bodyPr>
-          <a:lstStyle/>
-          <a:p>
-            <a:pPr>
-              <a:spcAft>
-                <a:spcPts val="200"/>
-              </a:spcAft>
-            </a:pPr>
-            <a:r>
-              <a:rPr lang="en-US" sz="2000" b="1">
-                <a:solidFill>
-                  <a:srgbClr val="000000"/>
-                </a:solidFill>
-                <a:latin typeface="Calibri" panose="020F0502020204030204" pitchFamily="34" charset="0"/>
-              </a:rPr>
-              <a:t>P(A)  =  (number of outcomes in A) / (number of outcomes in S)</a:t>
-            </a:r>
-          </a:p>
-        </p:txBody>
-      </p:sp>
-      <p:sp>
-        <p:nvSpPr>
-          <p:cNvPr id="10" name="Question">
-            <a:extLst>
-              <a:ext uri="{FF2B5EF4-FFF2-40B4-BE49-F238E27FC236}">
-                <a16:creationId xmlns:a16="http://schemas.microsoft.com/office/drawing/2014/main" id="{B31E395F-B84E-D1E9-D22A-222467FC4105}"/>
-              </a:ext>
-            </a:extLst>
-          </p:cNvPr>
-          <p:cNvSpPr txBox="1"/>
-          <p:nvPr/>
-        </p:nvSpPr>
-        <p:spPr>
-          <a:xfrm>
-            <a:off x="762000" y="2711510"/>
-            <a:ext cx="10668000" cy="671979"/>
-          </a:xfrm>
-          <a:prstGeom prst="rect">
-            <a:avLst/>
-          </a:prstGeom>
-          <a:noFill/>
-        </p:spPr>
-        <p:txBody>
-          <a:bodyPr vert="horz" wrap="square" rtlCol="0">
-            <a:spAutoFit/>
-          </a:bodyPr>
-          <a:lstStyle/>
-          <a:p>
-            <a:pPr>
-              <a:spcAft>
-                <a:spcPts val="200"/>
-              </a:spcAft>
-            </a:pPr>
-            <a:r>
-              <a:rPr lang="en-US" b="1">
-                <a:solidFill>
-                  <a:srgbClr val="C00000"/>
-                </a:solidFill>
-                <a:latin typeface="Calibri" panose="020F0502020204030204" pitchFamily="34" charset="0"/>
-              </a:rPr>
-              <a:t>(a)  What is P(even)?</a:t>
-            </a:r>
-          </a:p>
-          <a:p>
-            <a:pPr>
-              <a:spcAft>
-                <a:spcPts val="200"/>
-              </a:spcAft>
-            </a:pPr>
-            <a:r>
-              <a:rPr lang="en-US" b="1">
-                <a:solidFill>
-                  <a:srgbClr val="C00000"/>
-                </a:solidFill>
-                <a:latin typeface="Calibri" panose="020F0502020204030204" pitchFamily="34" charset="0"/>
-              </a:rPr>
-              <a:t>(b)  What is P(not a six)?</a:t>
-            </a:r>
-          </a:p>
-        </p:txBody>
-      </p:sp>
-      <p:sp>
-        <p:nvSpPr>
-          <p:cNvPr id="11" name="Result">
-            <a:extLst>
-              <a:ext uri="{FF2B5EF4-FFF2-40B4-BE49-F238E27FC236}">
-                <a16:creationId xmlns:a16="http://schemas.microsoft.com/office/drawing/2014/main" id="{5A70F68E-0D93-07B8-82B2-4D8F2F681D0D}"/>
-              </a:ext>
-            </a:extLst>
-          </p:cNvPr>
-          <p:cNvSpPr/>
-          <p:nvPr/>
-        </p:nvSpPr>
-        <p:spPr>
-          <a:xfrm>
-            <a:off x="762000" y="3535889"/>
-            <a:ext cx="10668000" cy="784324"/>
-          </a:xfrm>
-          <a:prstGeom prst="roundRect">
-            <a:avLst>
-              <a:gd name="adj" fmla="val 4000"/>
-            </a:avLst>
-          </a:prstGeom>
-          <a:solidFill>
-            <a:srgbClr val="F2F6FC"/>
-          </a:solidFill>
-          <a:ln w="15875">
-            <a:solidFill>
-              <a:srgbClr val="4472C4"/>
-            </a:solidFill>
-          </a:ln>
-        </p:spPr>
-        <p:style>
-          <a:lnRef idx="2">
-            <a:schemeClr val="accent1">
-              <a:shade val="15000"/>
-            </a:schemeClr>
-          </a:lnRef>
-          <a:fillRef idx="1">
-            <a:schemeClr val="accent1"/>
-          </a:fillRef>
-          <a:effectRef idx="0">
-            <a:schemeClr val="accent1"/>
-          </a:effectRef>
-          <a:fontRef idx="minor">
-            <a:schemeClr val="lt1"/>
-          </a:fontRef>
-        </p:style>
-        <p:txBody>
-          <a:bodyPr wrap="square" lIns="152400" tIns="76200" rIns="152400" bIns="76200" rtlCol="0" anchor="ctr">
-            <a:spAutoFit/>
-          </a:bodyPr>
-          <a:lstStyle/>
-          <a:p>
-            <a:r>
-              <a:rPr lang="pt-BR" sz="2000" b="1">
-                <a:solidFill>
-                  <a:srgbClr val="C00000"/>
-                </a:solidFill>
-                <a:latin typeface="Calibri" panose="020F0502020204030204" pitchFamily="34" charset="0"/>
-              </a:rPr>
-              <a:t>(a)  3 / 6 = 0.5</a:t>
-            </a:r>
-          </a:p>
-          <a:p>
-            <a:r>
-              <a:rPr lang="pt-BR" sz="2000" b="1">
-                <a:solidFill>
-                  <a:srgbClr val="C00000"/>
-                </a:solidFill>
-                <a:latin typeface="Calibri" panose="020F0502020204030204" pitchFamily="34" charset="0"/>
-              </a:rPr>
-              <a:t>(b)  5 / 6 ≈ 0.83</a:t>
-            </a:r>
-            <a:endParaRPr lang="en-US" sz="2000" b="1">
-              <a:solidFill>
-                <a:srgbClr val="C00000"/>
-              </a:solidFill>
-              <a:latin typeface="Calibri" panose="020F0502020204030204" pitchFamily="34" charset="0"/>
-            </a:endParaRPr>
-          </a:p>
-        </p:txBody>
-      </p:sp>
-    </p:spTree>
-    <p:extLst>
-      <p:ext uri="{BB962C8B-B14F-4D97-AF65-F5344CB8AC3E}">
-        <p14:creationId xmlns:p14="http://schemas.microsoft.com/office/powerpoint/2010/main" val="3005201489"/>
-      </p:ext>
-    </p:extLst>
-  </p:cSld>
-  <p:clrMapOvr>
-    <a:masterClrMapping/>
-  </p:clrMapOvr>
-  <p:timing>
-    <p:tnLst>
-      <p:par>
-        <p:cTn id="1" dur="indefinite" restart="never" nodeType="tmRoot">
-          <p:childTnLst>
-            <p:seq concurrent="1" nextAc="seek">
-              <p:cTn id="2" dur="indefinite" nodeType="mainSeq">
-                <p:childTnLst>
-                  <p:par>
-                    <p:cTn id="3" fill="hold">
-                      <p:stCondLst>
-                        <p:cond delay="indefinite"/>
-                      </p:stCondLst>
-                      <p:childTnLst>
-                        <p:par>
-                          <p:cTn id="4" fill="hold">
-                            <p:stCondLst>
-                              <p:cond delay="0"/>
-                            </p:stCondLst>
-                            <p:childTnLst>
-                              <p:par>
-                                <p:cTn id="5" presetID="1" presetClass="entr" presetSubtype="0" fill="hold" grpId="0" nodeType="clickEffect">
-                                  <p:stCondLst>
-                                    <p:cond delay="0"/>
-                                  </p:stCondLst>
-                                  <p:childTnLst>
-                                    <p:set>
-                                      <p:cBhvr>
-                                        <p:cTn id="6" dur="1" fill="hold">
-                                          <p:stCondLst>
-                                            <p:cond delay="0"/>
-                                          </p:stCondLst>
-                                        </p:cTn>
-                                        <p:tgtEl>
-                                          <p:spTgt spid="11"/>
-                                        </p:tgtEl>
-                                        <p:attrNameLst>
-                                          <p:attrName>style.visibility</p:attrName>
-                                        </p:attrNameLst>
-                                      </p:cBhvr>
-                                      <p:to>
-                                        <p:strVal val="visible"/>
-                                      </p:to>
-                                    </p:set>
-                                  </p:childTnLst>
-                                </p:cTn>
-                              </p:par>
-                            </p:childTnLst>
-                          </p:cTn>
-                        </p:par>
-                      </p:childTnLst>
-                    </p:cTn>
-                  </p:par>
-                </p:childTnLst>
-              </p:cTn>
-              <p:prevCondLst>
-                <p:cond evt="onPrev" delay="0">
-                  <p:tgtEl>
-                    <p:sldTgt/>
-                  </p:tgtEl>
-                </p:cond>
-              </p:prevCondLst>
-              <p:nextCondLst>
-                <p:cond evt="onNext" delay="0">
-                  <p:tgtEl>
-                    <p:sldTgt/>
-                  </p:tgtEl>
-                </p:cond>
-              </p:nextCondLst>
-            </p:seq>
-          </p:childTnLst>
-        </p:cTn>
-      </p:par>
-    </p:tnLst>
-    <p:bldLst>
-      <p:bldP spid="11" grpId="0" animBg="1"/>
-    </p:bldLst>
-  </p:timing>
-</p:sld>
-</file>
-
-<file path=ppt/slides/slide28.xml><?xml version="1.0" encoding="utf-8"?>
-<p:sld xmlns:a="http://schemas.openxmlformats.org/drawingml/2006/main" xmlns:r="http://schemas.openxmlformats.org/officeDocument/2006/relationships" xmlns:p="http://schemas.openxmlformats.org/presentationml/2006/main">
-  <p:cSld>
-    <p:spTree>
-      <p:nvGrpSpPr>
-        <p:cNvPr id="1" name=""/>
-        <p:cNvGrpSpPr/>
-        <p:nvPr/>
-      </p:nvGrpSpPr>
-      <p:grpSpPr>
-        <a:xfrm>
-          <a:off x="0" y="0"/>
-          <a:ext cx="0" cy="0"/>
-          <a:chOff x="0" y="0"/>
-          <a:chExt cx="0" cy="0"/>
-        </a:xfrm>
-      </p:grpSpPr>
-      <p:sp>
-        <p:nvSpPr>
-          <p:cNvPr id="2" name="Title 1">
-            <a:extLst>
-              <a:ext uri="{FF2B5EF4-FFF2-40B4-BE49-F238E27FC236}">
-                <a16:creationId xmlns:a16="http://schemas.microsoft.com/office/drawing/2014/main" id="{C08D30B1-1864-30EF-7EAB-9BEE656C0012}"/>
-              </a:ext>
-            </a:extLst>
-          </p:cNvPr>
-          <p:cNvSpPr>
-            <a:spLocks noGrp="1"/>
-          </p:cNvSpPr>
-          <p:nvPr>
-            <p:ph type="title"/>
-          </p:nvPr>
-        </p:nvSpPr>
-        <p:spPr/>
-        <p:txBody>
-          <a:bodyPr>
-            <a:noAutofit/>
-          </a:bodyPr>
-          <a:lstStyle/>
-          <a:p>
-            <a:r>
-              <a:rPr lang="en-US">
-                <a:solidFill>
-                  <a:srgbClr val="1F3864"/>
-                </a:solidFill>
-              </a:rPr>
-              <a:t>Example: probabilities from real data</a:t>
-            </a:r>
-          </a:p>
-        </p:txBody>
-      </p:sp>
-      <p:sp>
-        <p:nvSpPr>
-          <p:cNvPr id="4" name="Slide Number Placeholder 3">
-            <a:extLst>
-              <a:ext uri="{FF2B5EF4-FFF2-40B4-BE49-F238E27FC236}">
-                <a16:creationId xmlns:a16="http://schemas.microsoft.com/office/drawing/2014/main" id="{3F875068-D051-44AE-498E-1BEBEDE3A7C8}"/>
-              </a:ext>
-            </a:extLst>
-          </p:cNvPr>
-          <p:cNvSpPr>
-            <a:spLocks noGrp="1"/>
-          </p:cNvSpPr>
-          <p:nvPr>
-            <p:ph type="sldNum" sz="quarter" idx="12"/>
-          </p:nvPr>
-        </p:nvSpPr>
-        <p:spPr/>
-        <p:txBody>
-          <a:bodyPr/>
-          <a:lstStyle/>
-          <a:p>
-            <a:fld id="{A80A81DD-F10A-4B1C-963A-0ABBB4865886}" type="slidenum">
-              <a:rPr lang="en-US" sz="1600" smtClean="0"/>
-              <a:t>28</a:t>
-            </a:fld>
-            <a:endParaRPr lang="en-US" sz="1600"/>
-          </a:p>
-        </p:txBody>
-      </p:sp>
-      <p:sp>
-        <p:nvSpPr>
-          <p:cNvPr id="3" name="Title rule">
-            <a:extLst>
-              <a:ext uri="{FF2B5EF4-FFF2-40B4-BE49-F238E27FC236}">
-                <a16:creationId xmlns:a16="http://schemas.microsoft.com/office/drawing/2014/main" id="{30656AA8-9645-F028-C769-A313710853CC}"/>
-              </a:ext>
-            </a:extLst>
-          </p:cNvPr>
-          <p:cNvSpPr/>
-          <p:nvPr/>
-        </p:nvSpPr>
-        <p:spPr>
-          <a:xfrm>
-            <a:off x="838200" y="1600200"/>
-            <a:ext cx="10515600" cy="38100"/>
-          </a:xfrm>
-          <a:prstGeom prst="rect">
-            <a:avLst/>
-          </a:prstGeom>
-          <a:solidFill>
-            <a:srgbClr val="4472C4"/>
-          </a:solidFill>
-          <a:ln w="12700" cap="flat" cmpd="sng" algn="ctr">
-            <a:noFill/>
-            <a:prstDash val="solid"/>
-            <a:miter lim="800000"/>
-          </a:ln>
-          <a:effectLst/>
-          <a:extLst>
-            <a:ext uri="{91240B29-F687-4F45-9708-019B960494DF}">
-              <a14:hiddenLine xmlns:a14="http://schemas.microsoft.com/office/drawing/2010/main" w="12700" cap="flat" cmpd="sng" algn="ctr">
-                <a:solidFill>
-                  <a:schemeClr val="accent1">
-                    <a:shade val="15000"/>
-                  </a:schemeClr>
-                </a:solidFill>
-                <a:prstDash val="solid"/>
-                <a:miter lim="800000"/>
-              </a14:hiddenLine>
-            </a:ext>
-          </a:extLst>
-        </p:spPr>
-        <p:style>
-          <a:lnRef idx="2">
-            <a:schemeClr val="accent1">
-              <a:shade val="15000"/>
-            </a:schemeClr>
-          </a:lnRef>
-          <a:fillRef idx="1">
-            <a:schemeClr val="accent1"/>
-          </a:fillRef>
-          <a:effectRef idx="0">
-            <a:schemeClr val="accent1"/>
-          </a:effectRef>
-          <a:fontRef idx="minor">
-            <a:schemeClr val="lt1"/>
-          </a:fontRef>
-        </p:style>
-        <p:txBody>
-          <a:bodyPr rtlCol="0" anchor="ctr"/>
-          <a:lstStyle/>
-          <a:p>
-            <a:pPr algn="ctr"/>
-            <a:endParaRPr lang="en-US"/>
-          </a:p>
-        </p:txBody>
-      </p:sp>
-      <p:sp>
-        <p:nvSpPr>
-          <p:cNvPr id="8" name="Context">
-            <a:extLst>
-              <a:ext uri="{FF2B5EF4-FFF2-40B4-BE49-F238E27FC236}">
-                <a16:creationId xmlns:a16="http://schemas.microsoft.com/office/drawing/2014/main" id="{71E3EA8C-31B4-DAD4-BC4A-65D72E59AD46}"/>
-              </a:ext>
-            </a:extLst>
-          </p:cNvPr>
-          <p:cNvSpPr txBox="1"/>
-          <p:nvPr/>
-        </p:nvSpPr>
-        <p:spPr>
-          <a:xfrm>
-            <a:off x="762000" y="1879600"/>
-            <a:ext cx="10668000" cy="381000"/>
-          </a:xfrm>
-          <a:prstGeom prst="rect">
-            <a:avLst/>
-          </a:prstGeom>
-          <a:noFill/>
-        </p:spPr>
-        <p:txBody>
-          <a:bodyPr vert="horz" wrap="square" rtlCol="0">
-            <a:spAutoFit/>
-          </a:bodyPr>
-          <a:lstStyle/>
-          <a:p>
-            <a:pPr>
-              <a:spcAft>
-                <a:spcPts val="200"/>
-              </a:spcAft>
-            </a:pPr>
-            <a:r>
-              <a:rPr lang="en-US">
-                <a:solidFill>
-                  <a:srgbClr val="000000"/>
-                </a:solidFill>
-                <a:latin typeface="Calibri" panose="020F0502020204030204" pitchFamily="34" charset="0"/>
-              </a:rPr>
-              <a:t>Pick one of the 379 students from the heights data at random.</a:t>
-            </a:r>
-          </a:p>
-        </p:txBody>
-      </p:sp>
-      <p:sp>
-        <p:nvSpPr>
-          <p:cNvPr id="10" name="Question">
-            <a:extLst>
-              <a:ext uri="{FF2B5EF4-FFF2-40B4-BE49-F238E27FC236}">
-                <a16:creationId xmlns:a16="http://schemas.microsoft.com/office/drawing/2014/main" id="{B31E395F-B84E-D1E9-D22A-222467FC4105}"/>
-              </a:ext>
-            </a:extLst>
-          </p:cNvPr>
-          <p:cNvSpPr txBox="1"/>
-          <p:nvPr/>
-        </p:nvSpPr>
-        <p:spPr>
-          <a:xfrm>
-            <a:off x="762000" y="3830320"/>
-            <a:ext cx="10668000" cy="671979"/>
-          </a:xfrm>
-          <a:prstGeom prst="rect">
-            <a:avLst/>
-          </a:prstGeom>
-          <a:noFill/>
-        </p:spPr>
-        <p:txBody>
-          <a:bodyPr vert="horz" wrap="square" rtlCol="0">
-            <a:spAutoFit/>
-          </a:bodyPr>
-          <a:lstStyle/>
-          <a:p>
-            <a:pPr>
-              <a:spcAft>
-                <a:spcPts val="200"/>
-              </a:spcAft>
-            </a:pPr>
-            <a:r>
-              <a:rPr lang="en-US" b="1">
-                <a:solidFill>
-                  <a:srgbClr val="C00000"/>
-                </a:solidFill>
-                <a:latin typeface="Calibri" panose="020F0502020204030204" pitchFamily="34" charset="0"/>
-              </a:rPr>
-              <a:t>(a)  What is P(the student is at least 70 in)?</a:t>
-            </a:r>
-          </a:p>
-          <a:p>
-            <a:pPr>
-              <a:spcAft>
-                <a:spcPts val="200"/>
-              </a:spcAft>
-            </a:pPr>
-            <a:r>
-              <a:rPr lang="en-US" b="1">
-                <a:solidFill>
-                  <a:srgbClr val="C00000"/>
-                </a:solidFill>
-                <a:latin typeface="Calibri" panose="020F0502020204030204" pitchFamily="34" charset="0"/>
-              </a:rPr>
-              <a:t>(b)  What is P(the student is female)?</a:t>
-            </a:r>
-          </a:p>
-        </p:txBody>
-      </p:sp>
-      <p:sp>
-        <p:nvSpPr>
-          <p:cNvPr id="11" name="Result">
-            <a:extLst>
-              <a:ext uri="{FF2B5EF4-FFF2-40B4-BE49-F238E27FC236}">
-                <a16:creationId xmlns:a16="http://schemas.microsoft.com/office/drawing/2014/main" id="{5A70F68E-0D93-07B8-82B2-4D8F2F681D0D}"/>
-              </a:ext>
-            </a:extLst>
-          </p:cNvPr>
-          <p:cNvSpPr/>
-          <p:nvPr/>
-        </p:nvSpPr>
-        <p:spPr>
-          <a:xfrm>
-            <a:off x="762000" y="4629299"/>
-            <a:ext cx="10668000" cy="784324"/>
-          </a:xfrm>
-          <a:prstGeom prst="roundRect">
-            <a:avLst>
-              <a:gd name="adj" fmla="val 4000"/>
-            </a:avLst>
-          </a:prstGeom>
-          <a:solidFill>
-            <a:srgbClr val="F2F6FC"/>
-          </a:solidFill>
-          <a:ln w="15875">
-            <a:solidFill>
-              <a:srgbClr val="4472C4"/>
-            </a:solidFill>
-          </a:ln>
-        </p:spPr>
-        <p:style>
-          <a:lnRef idx="2">
-            <a:schemeClr val="accent1">
-              <a:shade val="15000"/>
-            </a:schemeClr>
-          </a:lnRef>
-          <a:fillRef idx="1">
-            <a:schemeClr val="accent1"/>
-          </a:fillRef>
-          <a:effectRef idx="0">
-            <a:schemeClr val="accent1"/>
-          </a:effectRef>
-          <a:fontRef idx="minor">
-            <a:schemeClr val="lt1"/>
-          </a:fontRef>
-        </p:style>
-        <p:txBody>
-          <a:bodyPr wrap="square" lIns="152400" tIns="76200" rIns="152400" bIns="76200" rtlCol="0" anchor="ctr">
-            <a:spAutoFit/>
-          </a:bodyPr>
-          <a:lstStyle/>
-          <a:p>
-            <a:r>
-              <a:rPr lang="pt-BR" sz="2000" b="1">
-                <a:solidFill>
-                  <a:srgbClr val="C00000"/>
-                </a:solidFill>
-                <a:latin typeface="Calibri" panose="020F0502020204030204" pitchFamily="34" charset="0"/>
-              </a:rPr>
-              <a:t>(a)  106 / 379 ≈ 0.28</a:t>
-            </a:r>
-          </a:p>
-          <a:p>
-            <a:r>
-              <a:rPr lang="pt-BR" sz="2000" b="1">
-                <a:solidFill>
-                  <a:srgbClr val="C00000"/>
-                </a:solidFill>
-                <a:latin typeface="Calibri" panose="020F0502020204030204" pitchFamily="34" charset="0"/>
-              </a:rPr>
-              <a:t>(b)  262 / 379 ≈ 0.69</a:t>
-            </a:r>
-            <a:endParaRPr lang="en-US" sz="2000" b="1">
-              <a:solidFill>
-                <a:srgbClr val="C00000"/>
-              </a:solidFill>
-              <a:latin typeface="Calibri" panose="020F0502020204030204" pitchFamily="34" charset="0"/>
-            </a:endParaRPr>
-          </a:p>
-        </p:txBody>
-      </p:sp>
-      <p:graphicFrame>
-        <p:nvGraphicFramePr>
-          <p:cNvPr id="5" name="Counts">
-            <a:extLst>
-              <a:ext uri="{FF2B5EF4-FFF2-40B4-BE49-F238E27FC236}">
-                <a16:creationId xmlns:a16="http://schemas.microsoft.com/office/drawing/2014/main" id="{07CBF5BB-B19C-04AA-D608-94962C8F3B35}"/>
-              </a:ext>
-            </a:extLst>
-          </p:cNvPr>
-          <p:cNvGraphicFramePr>
-            <a:graphicFrameLocks noGrp="1"/>
-          </p:cNvGraphicFramePr>
-          <p:nvPr>
-            <p:extLst>
-              <p:ext uri="{D42A27DB-BD31-4B8C-83A1-F6EECF244321}">
-                <p14:modId xmlns:p14="http://schemas.microsoft.com/office/powerpoint/2010/main" val="2650374605"/>
-              </p:ext>
-            </p:extLst>
-          </p:nvPr>
-        </p:nvGraphicFramePr>
-        <p:xfrm>
-          <a:off x="762000" y="2362200"/>
-          <a:ext cx="6604000" cy="1341120"/>
-        </p:xfrm>
-        <a:graphic>
-          <a:graphicData uri="http://schemas.openxmlformats.org/drawingml/2006/table">
-            <a:tbl>
-              <a:tblPr firstRow="1" bandRow="1">
-                <a:tableStyleId>{3B4B98B0-60AC-42C2-AFA5-B58CD77FA1E5}</a:tableStyleId>
-              </a:tblPr>
-              <a:tblGrid>
-                <a:gridCol w="1651000">
-                  <a:extLst>
-                    <a:ext uri="{9D8B030D-6E8A-4147-A177-3AD203B41FA5}">
-                      <a16:colId xmlns:a16="http://schemas.microsoft.com/office/drawing/2014/main" val="3902670300"/>
-                    </a:ext>
-                  </a:extLst>
-                </a:gridCol>
-                <a:gridCol w="1651000">
-                  <a:extLst>
-                    <a:ext uri="{9D8B030D-6E8A-4147-A177-3AD203B41FA5}">
-                      <a16:colId xmlns:a16="http://schemas.microsoft.com/office/drawing/2014/main" val="3866161889"/>
-                    </a:ext>
-                  </a:extLst>
-                </a:gridCol>
-                <a:gridCol w="1651000">
-                  <a:extLst>
-                    <a:ext uri="{9D8B030D-6E8A-4147-A177-3AD203B41FA5}">
-                      <a16:colId xmlns:a16="http://schemas.microsoft.com/office/drawing/2014/main" val="938379248"/>
-                    </a:ext>
-                  </a:extLst>
-                </a:gridCol>
-                <a:gridCol w="1651000">
-                  <a:extLst>
-                    <a:ext uri="{9D8B030D-6E8A-4147-A177-3AD203B41FA5}">
-                      <a16:colId xmlns:a16="http://schemas.microsoft.com/office/drawing/2014/main" val="1669086323"/>
-                    </a:ext>
-                  </a:extLst>
-                </a:gridCol>
-              </a:tblGrid>
-              <a:tr h="330200">
-                <a:tc>
-                  <a:txBody>
-                    <a:bodyPr/>
-                    <a:lstStyle/>
-                    <a:p>
-                      <a:endParaRPr lang="en-US" sz="1600" b="1">
-                        <a:latin typeface="Calibri" panose="020F0502020204030204" pitchFamily="34" charset="0"/>
-                      </a:endParaRPr>
-                    </a:p>
-                  </a:txBody>
-                  <a:tcPr/>
-                </a:tc>
-                <a:tc>
-                  <a:txBody>
-                    <a:bodyPr/>
-                    <a:lstStyle/>
-                    <a:p>
-                      <a:r>
-                        <a:rPr lang="en-US" sz="1600" b="1">
-                          <a:latin typeface="Calibri" panose="020F0502020204030204" pitchFamily="34" charset="0"/>
-                        </a:rPr>
-                        <a:t>At least 70 in</a:t>
-                      </a:r>
-                    </a:p>
-                  </a:txBody>
-                  <a:tcPr/>
-                </a:tc>
-                <a:tc>
-                  <a:txBody>
-                    <a:bodyPr/>
-                    <a:lstStyle/>
-                    <a:p>
-                      <a:r>
-                        <a:rPr lang="en-US" sz="1600" b="1">
-                          <a:latin typeface="Calibri" panose="020F0502020204030204" pitchFamily="34" charset="0"/>
-                        </a:rPr>
-                        <a:t>Under 70 in</a:t>
-                      </a:r>
-                    </a:p>
-                  </a:txBody>
-                  <a:tcPr/>
-                </a:tc>
-                <a:tc>
-                  <a:txBody>
-                    <a:bodyPr/>
-                    <a:lstStyle/>
-                    <a:p>
-                      <a:r>
-                        <a:rPr lang="en-US" sz="1600" b="1">
-                          <a:latin typeface="Calibri" panose="020F0502020204030204" pitchFamily="34" charset="0"/>
-                        </a:rPr>
-                        <a:t>Total</a:t>
-                      </a:r>
-                    </a:p>
-                  </a:txBody>
-                  <a:tcPr/>
-                </a:tc>
-                <a:extLst>
-                  <a:ext uri="{0D108BD9-81ED-4DB2-BD59-A6C34878D82A}">
-                    <a16:rowId xmlns:a16="http://schemas.microsoft.com/office/drawing/2014/main" val="3248346919"/>
-                  </a:ext>
-                </a:extLst>
-              </a:tr>
-              <a:tr h="330200">
-                <a:tc>
-                  <a:txBody>
-                    <a:bodyPr/>
-                    <a:lstStyle/>
-                    <a:p>
-                      <a:r>
-                        <a:rPr lang="en-US" sz="1600" b="1">
-                          <a:latin typeface="Calibri" panose="020F0502020204030204" pitchFamily="34" charset="0"/>
-                        </a:rPr>
-                        <a:t>Female</a:t>
-                      </a:r>
-                    </a:p>
-                  </a:txBody>
-                  <a:tcPr/>
-                </a:tc>
-                <a:tc>
-                  <a:txBody>
-                    <a:bodyPr/>
-                    <a:lstStyle/>
-                    <a:p>
-                      <a:r>
-                        <a:rPr lang="en-US" sz="1600">
-                          <a:latin typeface="Calibri" panose="020F0502020204030204" pitchFamily="34" charset="0"/>
-                        </a:rPr>
-                        <a:t>19</a:t>
-                      </a:r>
-                    </a:p>
-                  </a:txBody>
-                  <a:tcPr/>
-                </a:tc>
-                <a:tc>
-                  <a:txBody>
-                    <a:bodyPr/>
-                    <a:lstStyle/>
-                    <a:p>
-                      <a:r>
-                        <a:rPr lang="en-US" sz="1600">
-                          <a:latin typeface="Calibri" panose="020F0502020204030204" pitchFamily="34" charset="0"/>
-                        </a:rPr>
-                        <a:t>243</a:t>
-                      </a:r>
-                    </a:p>
-                  </a:txBody>
-                  <a:tcPr/>
-                </a:tc>
-                <a:tc>
-                  <a:txBody>
-                    <a:bodyPr/>
-                    <a:lstStyle/>
-                    <a:p>
-                      <a:r>
-                        <a:rPr lang="en-US" sz="1600">
-                          <a:latin typeface="Calibri" panose="020F0502020204030204" pitchFamily="34" charset="0"/>
-                        </a:rPr>
-                        <a:t>262</a:t>
-                      </a:r>
-                    </a:p>
-                  </a:txBody>
-                  <a:tcPr/>
-                </a:tc>
-                <a:extLst>
-                  <a:ext uri="{0D108BD9-81ED-4DB2-BD59-A6C34878D82A}">
-                    <a16:rowId xmlns:a16="http://schemas.microsoft.com/office/drawing/2014/main" val="1468173232"/>
-                  </a:ext>
-                </a:extLst>
-              </a:tr>
-              <a:tr h="330200">
-                <a:tc>
-                  <a:txBody>
-                    <a:bodyPr/>
-                    <a:lstStyle/>
-                    <a:p>
-                      <a:r>
-                        <a:rPr lang="en-US" sz="1600" b="1">
-                          <a:latin typeface="Calibri" panose="020F0502020204030204" pitchFamily="34" charset="0"/>
-                        </a:rPr>
-                        <a:t>Male</a:t>
-                      </a:r>
-                    </a:p>
-                  </a:txBody>
-                  <a:tcPr/>
-                </a:tc>
-                <a:tc>
-                  <a:txBody>
-                    <a:bodyPr/>
-                    <a:lstStyle/>
-                    <a:p>
-                      <a:r>
-                        <a:rPr lang="en-US" sz="1600">
-                          <a:latin typeface="Calibri" panose="020F0502020204030204" pitchFamily="34" charset="0"/>
-                        </a:rPr>
-                        <a:t>87</a:t>
-                      </a:r>
-                    </a:p>
-                  </a:txBody>
-                  <a:tcPr/>
-                </a:tc>
-                <a:tc>
-                  <a:txBody>
-                    <a:bodyPr/>
-                    <a:lstStyle/>
-                    <a:p>
-                      <a:r>
-                        <a:rPr lang="en-US" sz="1600">
-                          <a:latin typeface="Calibri" panose="020F0502020204030204" pitchFamily="34" charset="0"/>
-                        </a:rPr>
-                        <a:t>30</a:t>
-                      </a:r>
-                    </a:p>
-                  </a:txBody>
-                  <a:tcPr/>
-                </a:tc>
-                <a:tc>
-                  <a:txBody>
-                    <a:bodyPr/>
-                    <a:lstStyle/>
-                    <a:p>
-                      <a:r>
-                        <a:rPr lang="en-US" sz="1600">
-                          <a:latin typeface="Calibri" panose="020F0502020204030204" pitchFamily="34" charset="0"/>
-                        </a:rPr>
-                        <a:t>117</a:t>
-                      </a:r>
-                    </a:p>
-                  </a:txBody>
-                  <a:tcPr/>
-                </a:tc>
-                <a:extLst>
-                  <a:ext uri="{0D108BD9-81ED-4DB2-BD59-A6C34878D82A}">
-                    <a16:rowId xmlns:a16="http://schemas.microsoft.com/office/drawing/2014/main" val="1939953392"/>
-                  </a:ext>
-                </a:extLst>
-              </a:tr>
-              <a:tr h="330200">
-                <a:tc>
-                  <a:txBody>
-                    <a:bodyPr/>
-                    <a:lstStyle/>
-                    <a:p>
-                      <a:r>
-                        <a:rPr lang="en-US" sz="1600" b="1">
-                          <a:latin typeface="Calibri" panose="020F0502020204030204" pitchFamily="34" charset="0"/>
-                        </a:rPr>
-                        <a:t>Total</a:t>
-                      </a:r>
-                    </a:p>
-                  </a:txBody>
-                  <a:tcPr/>
-                </a:tc>
-                <a:tc>
-                  <a:txBody>
-                    <a:bodyPr/>
-                    <a:lstStyle/>
-                    <a:p>
-                      <a:r>
-                        <a:rPr lang="en-US" sz="1600">
-                          <a:latin typeface="Calibri" panose="020F0502020204030204" pitchFamily="34" charset="0"/>
-                        </a:rPr>
-                        <a:t>106</a:t>
-                      </a:r>
-                    </a:p>
-                  </a:txBody>
-                  <a:tcPr/>
-                </a:tc>
-                <a:tc>
-                  <a:txBody>
-                    <a:bodyPr/>
-                    <a:lstStyle/>
-                    <a:p>
-                      <a:r>
-                        <a:rPr lang="en-US" sz="1600">
-                          <a:latin typeface="Calibri" panose="020F0502020204030204" pitchFamily="34" charset="0"/>
-                        </a:rPr>
-                        <a:t>273</a:t>
-                      </a:r>
-                    </a:p>
-                  </a:txBody>
-                  <a:tcPr/>
-                </a:tc>
-                <a:tc>
-                  <a:txBody>
-                    <a:bodyPr/>
-                    <a:lstStyle/>
-                    <a:p>
-                      <a:r>
-                        <a:rPr lang="en-US" sz="1600">
-                          <a:latin typeface="Calibri" panose="020F0502020204030204" pitchFamily="34" charset="0"/>
-                        </a:rPr>
-                        <a:t>379</a:t>
-                      </a:r>
-                    </a:p>
-                  </a:txBody>
-                  <a:tcPr/>
-                </a:tc>
-                <a:extLst>
-                  <a:ext uri="{0D108BD9-81ED-4DB2-BD59-A6C34878D82A}">
-                    <a16:rowId xmlns:a16="http://schemas.microsoft.com/office/drawing/2014/main" val="4016138625"/>
-                  </a:ext>
-                </a:extLst>
-              </a:tr>
-            </a:tbl>
-          </a:graphicData>
-        </a:graphic>
-      </p:graphicFrame>
-    </p:spTree>
-    <p:extLst>
-      <p:ext uri="{BB962C8B-B14F-4D97-AF65-F5344CB8AC3E}">
-        <p14:creationId xmlns:p14="http://schemas.microsoft.com/office/powerpoint/2010/main" val="2055396939"/>
       </p:ext>
     </p:extLst>
   </p:cSld>

</xml_diff>